<commit_message>
Sprint 2: T-49 publicada en la prueba interna de Google Play
Decision 10.45. Version 1 (1.0.0) publicada el 3-oct; T-49 sigue en curso hasta instalarla en el Honor desde Play. Tablero v32, documento y presentacion del Incremento 2 al 3-oct.
</commit_message>
<xml_diff>
--- a/docs/BayStream_Incremento2_Presentacion.pptx
+++ b/docs/BayStream_Incremento2_Presentacion.pptx
@@ -119,12 +119,12 @@
   <p:extLst>
     <p:ext uri="{521415D9-36F7-43E2-AB2F-B90AF26B5E84}">
       <p14:sectionLst xmlns:p14="http://schemas.microsoft.com/office/powerpoint/2010/main">
-        <p14:section name="Apertura" id="{6159097b-15a7-4d93-8582-b5b58966731e}">
+        <p14:section name="Apertura" id="{448336b7-3455-0d09-ab29-b99281906fbf}">
           <p14:sldIdLst>
             <p14:sldId id="256"/>
           </p14:sldIdLst>
         </p14:section>
-        <p14:section name="Revisión del sprint" id="{6bf11a25-47e7-6360-5165-a0b72725cb4d}">
+        <p14:section name="Revisión del sprint" id="{d01897ea-3d64-e347-7531-36bcf4bb7f75}">
           <p14:sldIdLst>
             <p14:sldId id="257"/>
             <p14:sldId id="258"/>
@@ -132,7 +132,7 @@
             <p14:sldId id="260"/>
           </p14:sldIdLst>
         </p14:section>
-        <p14:section name="Calidad y seguridad" id="{e771bbdc-032b-999f-bc0a-94c5dd01f6c2}">
+        <p14:section name="Calidad y seguridad" id="{8671e49d-1509-4bbe-e5cb-c91457344502}">
           <p14:sldIdLst>
             <p14:sldId id="261"/>
             <p14:sldId id="262"/>
@@ -140,18 +140,18 @@
             <p14:sldId id="264"/>
           </p14:sldIdLst>
         </p14:section>
-        <p14:section name="Despliegue" id="{b24e1725-e405-3006-3d8e-1b091c738fe1}">
+        <p14:section name="Despliegue" id="{f3090655-31a6-8e55-5e55-31164f0e1b1a}">
           <p14:sldIdLst>
             <p14:sldId id="265"/>
           </p14:sldIdLst>
         </p14:section>
-        <p14:section name="Retrospectiva" id="{a0ea6445-0494-ff60-e86f-ac995d2c7c9b}">
+        <p14:section name="Retrospectiva" id="{f79e5873-27cc-7d3a-1730-f2ab51ab2071}">
           <p14:sldIdLst>
             <p14:sldId id="266"/>
             <p14:sldId id="267"/>
           </p14:sldIdLst>
         </p14:section>
-        <p14:section name="Cierre" id="{f766d228-b011-6f52-2a77-53402792d485}">
+        <p14:section name="Cierre" id="{42ca0016-c4cd-d5fe-e877-15268d2c793e}">
           <p14:sldIdLst>
             <p14:sldId id="268"/>
           </p14:sldIdLst>
@@ -918,7 +918,7 @@
           <a:p>
             <a:r>
               <a:rPr lang="en-US" dirty="0"/>
-              <a:t>La Web está publicada y es exactamente el mismo archivo que medimos. Android está firmado con la clave de subida; la clave está respaldada fuera del repositorio. La prueba interna espera a que Google apruebe mi identidad. Si pregunta por la tienda pública: Google pide 12 testers durante 14 días antes de producción, y eso va después.</a:t>
+              <a:t>La Web está publicada y es exactamente el mismo archivo que medimos. Android está firmado con la clave de subida, que está respaldada fuera del repositorio, y la versión 1 ya está publicada en la prueba interna. Si pregunta por la tienda pública: Google pide 12 testers durante 14 días antes de producción, y eso va después.</a:t>
             </a:r>
             <a:endParaRPr lang="en-US" dirty="0"/>
           </a:p>
@@ -1182,7 +1182,7 @@
           <a:p>
             <a:r>
               <a:rPr lang="en-US" dirty="0"/>
-              <a:t>Cierro con el estado. El sprint cumplió su objetivo; lo único abierto depende de Google. La semana del 18 al 24 queda para el manual, la presentación final y decidir qué requerimientos no funcionales se miden.</a:t>
+              <a:t>Cierro con el estado. El sprint cumplió su objetivo; la app ya está en la prueba interna de Google Play. La semana del 18 al 24 queda para el manual, la presentación final y decidir qué requerimientos no funcionales se miden.</a:t>
             </a:r>
             <a:endParaRPr lang="en-US" dirty="0"/>
           </a:p>
@@ -1270,7 +1270,7 @@
           <a:p>
             <a:r>
               <a:rPr lang="en-US" dirty="0"/>
-              <a:t>Los números del sprint. 25 de 26 tareas terminadas, 33 de 35 horas. La tarea abierta es la publicación en Google Play: el paquete está firmado y verificado, pero la cuenta espera la verificación de identidad que hace Google. La holgura del 34 por ciento se reservó para lo que destapara la verificación con archivos reales, y se usó casi completa en eso.</a:t>
+              <a:t>Los números del sprint. 25 de 26 tareas terminadas, 33 de 35 horas. La tarea abierta es T‑49: la app ya está publicada en la prueba interna de Google Play desde el 3 de octubre, y solo falta comprobar su instalación desde la tienda en el teléfono. La holgura del 34 por ciento se reservó para lo que destapara la verificación con archivos reales, y se usó casi completa en eso.</a:t>
             </a:r>
             <a:endParaRPr lang="en-US" dirty="0"/>
           </a:p>
@@ -3504,7 +3504,7 @@
                   <a:schemeClr val="bg1"/>
                 </a:solidFill>
               </a:rPr>
-              <a:t>Firmado</a:t>
+              <a:t>Publicado</a:t>
             </a:r>
             <a:endParaRPr lang="en-US" sz="1100" dirty="0"/>
           </a:p>
@@ -3540,7 +3540,7 @@
                   <a:schemeClr val="accent3"/>
                 </a:solidFill>
               </a:rPr>
-              <a:t>Paquete .aab con la clave de subida</a:t>
+              <a:t>Prueba interna de Google Play</a:t>
             </a:r>
             <a:endParaRPr lang="en-US" sz="1300" dirty="0"/>
           </a:p>
@@ -3576,7 +3576,7 @@
                   <a:schemeClr val="tx2"/>
                 </a:solidFill>
               </a:rPr>
-              <a:t>Verificado. La publicación en la prueba interna de Google Play espera la verificación de identidad.</a:t>
+              <a:t>Versión 1 (1.0.0) publicada el 3 de octubre. Falta instalarla en el teléfono desde la tienda.</a:t>
             </a:r>
             <a:endParaRPr lang="en-US" sz="1350" dirty="0"/>
           </a:p>
@@ -5485,7 +5485,7 @@
                 <a:ea typeface="Calibri" pitchFamily="34" charset="-122"/>
                 <a:cs typeface="Calibri" pitchFamily="34" charset="-120"/>
               </a:rPr>
-              <a:t>El sprint cumplió su objetivo; lo único abierto depende de Google.</a:t>
+              <a:t>El sprint cumplió su objetivo; solo falta instalar desde Play la versión publicada.</a:t>
             </a:r>
             <a:endParaRPr lang="en-US" sz="1400" dirty="0"/>
           </a:p>
@@ -5861,7 +5861,7 @@
                   <a:srgbClr val="D6D2CB"/>
                 </a:solidFill>
               </a:rPr>
-              <a:t>Prueba interna en cuanto Google apruebe la identidad; luego, la prueba cerrada</a:t>
+              <a:t>Prueba interna publicada el 3‑oct; instalar en el Honor y abrir la prueba cerrada</a:t>
             </a:r>
             <a:endParaRPr lang="en-US" sz="1400" dirty="0"/>
           </a:p>
@@ -6141,7 +6141,7 @@
                 <a:ea typeface="Calibri" pitchFamily="34" charset="-122"/>
                 <a:cs typeface="Calibri" pitchFamily="34" charset="-120"/>
               </a:rPr>
-              <a:t>Estado al 2 de octubre de 2026. Una sola tarea comprometida sigue abierta, y depende de Google.</a:t>
+              <a:t>Estado al 3 de octubre de 2026. Solo falta instalar desde Google Play la versión ya publicada.</a:t>
             </a:r>
             <a:endParaRPr lang="en-US" sz="1400" dirty="0"/>
           </a:p>
@@ -6377,7 +6377,7 @@
                   <a:schemeClr val="tx2"/>
                 </a:solidFill>
               </a:rPr>
-              <a:t>T‑49 firmada; su publicación espera a Google</a:t>
+              <a:t>T‑49 publicada en la prueba interna; falta instalarla</a:t>
             </a:r>
             <a:endParaRPr lang="en-US" sz="1150" dirty="0"/>
           </a:p>
@@ -6713,7 +6713,7 @@
                 <a:ea typeface="Cambria" pitchFamily="34" charset="-122"/>
                 <a:cs typeface="Cambria" pitchFamily="34" charset="-120"/>
               </a:rPr>
-              <a:t>81</a:t>
+              <a:t>82</a:t>
             </a:r>
             <a:endParaRPr lang="en-US" sz="3800" dirty="0"/>
           </a:p>
@@ -6785,7 +6785,7 @@
                   <a:schemeClr val="tx2"/>
                 </a:solidFill>
               </a:rPr>
-              <a:t>del 19‑sep al 2‑oct, trazables</a:t>
+              <a:t>del 19‑sep al 3‑oct, trazables</a:t>
             </a:r>
             <a:endParaRPr lang="en-US" sz="1150" dirty="0"/>
           </a:p>
@@ -8330,7 +8330,7 @@
                   <a:schemeClr val="tx2"/>
                 </a:solidFill>
               </a:rPr>
-              <a:t>Proyecto de producción y Web publicada; el paquete Android, firmado, espera la prueba interna.</a:t>
+              <a:t>Proyecto de producción, Web publicada y app en la prueba interna de Google Play; falta instalarla desde la tienda.</a:t>
             </a:r>
             <a:endParaRPr lang="en-US" sz="1250" dirty="0"/>
           </a:p>
@@ -12953,7 +12953,7 @@
                   <a:schemeClr val="tx2"/>
                 </a:solidFill>
               </a:rPr>
-              <a:t>Selección de 10 de 19. La tabla completa está en el documento (Tabla 83). Historial verificado el 2‑oct‑2026.</a:t>
+              <a:t>Selección de 10 de 19. La tabla completa está en el documento (Tabla 83). Historial verificado el 3‑oct‑2026.</a:t>
             </a:r>
             <a:endParaRPr lang="en-US" sz="1100" dirty="0"/>
           </a:p>

</xml_diff>

<commit_message>
Sprint 2: prueba de campo del MAGELLAN STAR, H3 corregida y decisiones de RNF
Decisiones 10.46 y 10.47: cuatro defectos encontrados con los planos reales de llegada y de carga pasan al Sprint 3 (pesos solo VGM, peso por pila sin VGM, 'de paso' invertido en llegada, celdas reservadas sin numero descartadas). Parrafo de H3 corregido en el documento y las diapositivas 11 a 13. docs/T63-DECISIONES-RNF.md fija los criterios de T-63 y el orden de medicion.
</commit_message>
<xml_diff>
--- a/docs/BayStream_Incremento2_Presentacion.pptx
+++ b/docs/BayStream_Incremento2_Presentacion.pptx
@@ -119,12 +119,12 @@
   <p:extLst>
     <p:ext uri="{521415D9-36F7-43E2-AB2F-B90AF26B5E84}">
       <p14:sectionLst xmlns:p14="http://schemas.microsoft.com/office/powerpoint/2010/main">
-        <p14:section name="Apertura" id="{448336b7-3455-0d09-ab29-b99281906fbf}">
+        <p14:section name="Apertura" id="{b9c104cf-0678-7064-0a9a-09c9f9800e10}">
           <p14:sldIdLst>
             <p14:sldId id="256"/>
           </p14:sldIdLst>
         </p14:section>
-        <p14:section name="Revisión del sprint" id="{d01897ea-3d64-e347-7531-36bcf4bb7f75}">
+        <p14:section name="Revisión del sprint" id="{963b803e-ffc4-9de9-94f0-06a01ac13b1f}">
           <p14:sldIdLst>
             <p14:sldId id="257"/>
             <p14:sldId id="258"/>
@@ -132,7 +132,7 @@
             <p14:sldId id="260"/>
           </p14:sldIdLst>
         </p14:section>
-        <p14:section name="Calidad y seguridad" id="{8671e49d-1509-4bbe-e5cb-c91457344502}">
+        <p14:section name="Calidad y seguridad" id="{06e0c74f-3430-c9cf-271a-cd04c96aeef3}">
           <p14:sldIdLst>
             <p14:sldId id="261"/>
             <p14:sldId id="262"/>
@@ -140,18 +140,18 @@
             <p14:sldId id="264"/>
           </p14:sldIdLst>
         </p14:section>
-        <p14:section name="Despliegue" id="{f3090655-31a6-8e55-5e55-31164f0e1b1a}">
+        <p14:section name="Despliegue" id="{3f70959b-178e-614c-e999-eaa91e725b4f}">
           <p14:sldIdLst>
             <p14:sldId id="265"/>
           </p14:sldIdLst>
         </p14:section>
-        <p14:section name="Retrospectiva" id="{f79e5873-27cc-7d3a-1730-f2ab51ab2071}">
+        <p14:section name="Retrospectiva" id="{20d18b8d-79ba-6cdd-4cea-083e762d30c1}">
           <p14:sldIdLst>
             <p14:sldId id="266"/>
             <p14:sldId id="267"/>
           </p14:sldIdLst>
         </p14:section>
-        <p14:section name="Cierre" id="{42ca0016-c4cd-d5fe-e877-15268d2c793e}">
+        <p14:section name="Cierre" id="{f6e48540-7f55-cb5b-13e3-81e58dd282ff}">
           <p14:sldIdLst>
             <p14:sldId id="268"/>
           </p14:sldIdLst>
@@ -1094,7 +1094,7 @@
           <a:p>
             <a:r>
               <a:rPr lang="en-US" dirty="0"/>
-              <a:t>H3: el sprint construye el instrumento, pero el indicador necesita escenarios simulados que todavía no ejecutamos. H4: la evidencia es consistente en la construcción, pero el aseguramiento se multiplica por tres. H5: la serie de latencia está intacta, pero el producto no sincroniza por Firestore; cómo se reporta eso en la tesis es una decisión pendiente.</a:t>
+              <a:t>H3: el instrumento que pide la tesis es el módulo de muelle de los casos de uso CU04 y CU10, y ningún requerimiento funcional lo recogió. Lo detectamos al planificar el Sprint 3, donde entra como requerimiento nuevo; las reglas de RF‑027 son la pieza que ese módulo aplicará. H4: la evidencia es consistente en la construcción, pero el aseguramiento se multiplica por tres. H5: la serie de latencia está intacta, pero el producto no sincroniza por Firestore; cómo se reporta eso en la tesis es una decisión pendiente.</a:t>
             </a:r>
             <a:endParaRPr lang="en-US" dirty="0"/>
           </a:p>
@@ -1182,7 +1182,7 @@
           <a:p>
             <a:r>
               <a:rPr lang="en-US" dirty="0"/>
-              <a:t>Cierro con el estado. El sprint cumplió su objetivo; la app ya está en la prueba interna de Google Play. La semana del 18 al 24 queda para el manual, la presentación final y decidir qué requerimientos no funcionales se miden.</a:t>
+              <a:t>Cierro con el estado. El sprint cumplió su objetivo; la app ya está en la prueba interna de Google Play. El Sprint 3 cierra el 24 de octubre con el módulo de muelle sincronizado, las tapas de escotilla, el plan de carga, el BAPLIE de salida, el manual y la presentación final.</a:t>
             </a:r>
             <a:endParaRPr lang="en-US" dirty="0"/>
           </a:p>
@@ -4637,7 +4637,7 @@
                   <a:schemeClr val="tx1"/>
                 </a:solidFill>
               </a:rPr>
-              <a:t>Retomar T‑56 y la Web sin conexión</a:t>
+              <a:t>Convertir en requerimiento el módulo de muelle (CU04 y CU10)</a:t>
             </a:r>
             <a:endParaRPr lang="en-US" sz="1350" dirty="0"/>
           </a:p>
@@ -4825,7 +4825,7 @@
                 <a:ea typeface="Calibri" pitchFamily="34" charset="-122"/>
                 <a:cs typeface="Calibri" pitchFamily="34" charset="-120"/>
               </a:rPr>
-              <a:t>El sprint construye instrumentos y aporta matices; no mide los indicadores.</a:t>
+              <a:t>Ningún indicador se mide todavía, y H3 espera un módulo que ningún requerimiento recogió.</a:t>
             </a:r>
             <a:endParaRPr lang="en-US" sz="1400" dirty="0"/>
           </a:p>
@@ -5061,7 +5061,7 @@
                   <a:schemeClr val="tx2"/>
                 </a:solidFill>
               </a:rPr>
-              <a:t>El motor existe y se validó sobre el corpus real. Falta el indicador: escenarios simulados con detecciones correctas e incorrectas, y decidir cómo se cuenta un «no evaluado».</a:t>
+              <a:t>El módulo de muelle que exige H3 (CU04 y CU10) no existe: ningún requerimiento lo recogió. RF‑027 aporta las reglas que aplicará. Entra al Sprint 3.</a:t>
             </a:r>
             <a:endParaRPr lang="en-US" sz="1400" dirty="0"/>
           </a:p>
@@ -5917,7 +5917,7 @@
                   <a:schemeClr val="bg1"/>
                 </a:solidFill>
               </a:rPr>
-              <a:t>18 a 24 de octubre</a:t>
+              <a:t>Sprint 3, hasta el 24‑oct</a:t>
             </a:r>
             <a:endParaRPr lang="en-US" sz="1600" dirty="0"/>
           </a:p>
@@ -5953,7 +5953,7 @@
                   <a:srgbClr val="D6D2CB"/>
                 </a:solidFill>
               </a:rPr>
-              <a:t>Manual de usuario y presentación final; decidir qué RNF se miden</a:t>
+              <a:t>Módulo de muelle sincronizado, tapas, plan de carga, BAPLIE de salida, manual y presentación final</a:t>
             </a:r>
             <a:endParaRPr lang="en-US" sz="1400" dirty="0"/>
           </a:p>

</xml_diff>

<commit_message>
Sprint 2 cerrado: T-49 terminada, 26 de 26 tareas y 35.0 h
Decision 10.49: la app instalada desde Google Play arranca sin red y abre un plan real. Entrega del 17-oct con corte al 6-oct: documento con el apartado III.G de la prueba de campo (Tabla 89, Tablas 77-90), presentacion de 14 diapositivas y tablero 26/26. RNF ajustados a pantallas de 1920x1080 y a Windows 11 con Windows 10 en uso. Caso MAGELLAN STAR con las respuestas de Carlos y el IMDG 42-24 recibido, fuera del repositorio.
</commit_message>
<xml_diff>
--- a/docs/BayStream_Incremento2_Presentacion.pptx
+++ b/docs/BayStream_Incremento2_Presentacion.pptx
@@ -18,9 +18,10 @@
     <p:sldId id="266" r:id="rId12"/>
     <p:sldId id="267" r:id="rId13"/>
     <p:sldId id="268" r:id="rId14"/>
+    <p:sldId id="269" r:id="rId15"/>
   </p:sldIdLst>
   <p:notesMasterIdLst>
-    <p:notesMasterId r:id="rId15"/>
+    <p:notesMasterId r:id="rId16"/>
   </p:notesMasterIdLst>
   <p:sldSz cx="12192000" cy="6858000"/>
   <p:notesSz cx="6858000" cy="12192000"/>
@@ -119,12 +120,12 @@
   <p:extLst>
     <p:ext uri="{521415D9-36F7-43E2-AB2F-B90AF26B5E84}">
       <p14:sectionLst xmlns:p14="http://schemas.microsoft.com/office/powerpoint/2010/main">
-        <p14:section name="Apertura" id="{b9c104cf-0678-7064-0a9a-09c9f9800e10}">
+        <p14:section name="Apertura" id="{f34e2ecd-67b2-75c6-d83a-1c4b94f3bff7}">
           <p14:sldIdLst>
             <p14:sldId id="256"/>
           </p14:sldIdLst>
         </p14:section>
-        <p14:section name="Revisión del sprint" id="{963b803e-ffc4-9de9-94f0-06a01ac13b1f}">
+        <p14:section name="Revisión del sprint" id="{8dcd088b-3183-65af-5a2d-e3a3fd33cf38}">
           <p14:sldIdLst>
             <p14:sldId id="257"/>
             <p14:sldId id="258"/>
@@ -132,7 +133,7 @@
             <p14:sldId id="260"/>
           </p14:sldIdLst>
         </p14:section>
-        <p14:section name="Calidad y seguridad" id="{06e0c74f-3430-c9cf-271a-cd04c96aeef3}">
+        <p14:section name="Calidad y seguridad" id="{a40b020c-3ee9-14e6-fb23-5908c2e9daff}">
           <p14:sldIdLst>
             <p14:sldId id="261"/>
             <p14:sldId id="262"/>
@@ -140,20 +141,21 @@
             <p14:sldId id="264"/>
           </p14:sldIdLst>
         </p14:section>
-        <p14:section name="Despliegue" id="{3f70959b-178e-614c-e999-eaa91e725b4f}">
+        <p14:section name="Despliegue" id="{35319b63-41ea-7aa8-831d-9b97a709315a}">
           <p14:sldIdLst>
             <p14:sldId id="265"/>
+            <p14:sldId id="266"/>
           </p14:sldIdLst>
         </p14:section>
-        <p14:section name="Retrospectiva" id="{20d18b8d-79ba-6cdd-4cea-083e762d30c1}">
+        <p14:section name="Retrospectiva" id="{183303c4-85b7-184c-f668-24debcbd4f12}">
           <p14:sldIdLst>
-            <p14:sldId id="266"/>
             <p14:sldId id="267"/>
+            <p14:sldId id="268"/>
           </p14:sldIdLst>
         </p14:section>
-        <p14:section name="Cierre" id="{f6e48540-7f55-cb5b-13e3-81e58dd282ff}">
+        <p14:section name="Cierre" id="{56a9472f-63af-82f1-7086-13516992ed70}">
           <p14:sldIdLst>
-            <p14:sldId id="268"/>
+            <p14:sldId id="269"/>
           </p14:sldIdLst>
         </p14:section>
       </p14:sectionLst>
@@ -918,7 +920,7 @@
           <a:p>
             <a:r>
               <a:rPr lang="en-US" dirty="0"/>
-              <a:t>La Web está publicada y es exactamente el mismo archivo que medimos. Android está firmado con la clave de subida, que está respaldada fuera del repositorio, y la versión 1 ya está publicada en la prueba interna. Si pregunta por la tienda pública: Google pide 12 testers durante 14 días antes de producción, y eso va después.</a:t>
+              <a:t>La Web está publicada y es exactamente el mismo archivo que medimos. Android está firmado con la clave de subida, que está respaldada fuera del repositorio; la versión 1 está en la prueba interna, instalada desde la tienda en el teléfono, y arranca sin conexión. Si pregunta por la tienda pública: Google pide 12 testers durante 14 días antes de producción, y eso va después.</a:t>
             </a:r>
             <a:endParaRPr lang="en-US" dirty="0"/>
           </a:p>
@@ -1006,7 +1008,7 @@
           <a:p>
             <a:r>
               <a:rPr lang="en-US" dirty="0"/>
-              <a:t>Lo que más pesó en contra fue mío como organizador: los trámites de Google se planearon para el primer día y empezaron el día 13, por eso la publicación en Play es lo único abierto. Lo que más funcionó fue la doble prueba: cuando otro revisa, aparecen errores que el primero dio por buenos, incluidos los de quien planifica.</a:t>
+              <a:t>Entre el 5 y el 6 de octubre usé la app con los archivos de una escala real: el plano de llegada en la Web desde el iPhone y el plan de carga en el teléfono instalado desde Play. Encontré cuatro defectos; tres se podían ver con el corpus y no los buscamos, porque la aceptación revisaba las reglas y no la pantalla. Además, cuadré la operación completa: el listado, el plan y el plano que anoté a mano coinciden en los 176 movimientos. Así se trabaja hoy en el muelle, y eso es lo que el módulo del Sprint 3 tiene que reemplazar.</a:t>
             </a:r>
             <a:endParaRPr lang="en-US" dirty="0"/>
           </a:p>
@@ -1094,7 +1096,7 @@
           <a:p>
             <a:r>
               <a:rPr lang="en-US" dirty="0"/>
-              <a:t>H3: el instrumento que pide la tesis es el módulo de muelle de los casos de uso CU04 y CU10, y ningún requerimiento funcional lo recogió. Lo detectamos al planificar el Sprint 3, donde entra como requerimiento nuevo; las reglas de RF‑027 son la pieza que ese módulo aplicará. H4: la evidencia es consistente en la construcción, pero el aseguramiento se multiplica por tres. H5: la serie de latencia está intacta, pero el producto no sincroniza por Firestore; cómo se reporta eso en la tesis es una decisión pendiente.</a:t>
+              <a:t>Lo que más pesó en contra fue mío como organizador: los trámites de Google se planearon para el primer día y empezaron el día 13, por eso la publicación en Play llegó al final. Lo que más funcionó fue la doble prueba: cuando otro revisa, aparecen errores que el primero dio por buenos, incluidos los de quien planifica.</a:t>
             </a:r>
             <a:endParaRPr lang="en-US" dirty="0"/>
           </a:p>
@@ -1182,7 +1184,7 @@
           <a:p>
             <a:r>
               <a:rPr lang="en-US" dirty="0"/>
-              <a:t>Cierro con el estado. El sprint cumplió su objetivo; la app ya está en la prueba interna de Google Play. El Sprint 3 cierra el 24 de octubre con el módulo de muelle sincronizado, las tapas de escotilla, el plan de carga, el BAPLIE de salida, el manual y la presentación final.</a:t>
+              <a:t>H3: el instrumento que pide la tesis es el módulo de muelle de los casos de uso CU04 y CU10, y ningún requerimiento funcional lo recogió. Lo detectamos al planificar el Sprint 3, donde entra como requerimiento nuevo; las reglas de RF‑027 son la pieza que ese módulo aplicará. H4: la evidencia es consistente en la construcción, pero el aseguramiento se multiplica por tres. H5: la serie de latencia está intacta, pero el producto no sincroniza por Firestore; cómo se reporta eso en la tesis es una decisión pendiente.</a:t>
             </a:r>
             <a:endParaRPr lang="en-US" dirty="0"/>
           </a:p>
@@ -1206,6 +1208,94 @@
             <a:fld id="{F7021451-1387-4CA6-816F-3879F97B5CBC}" type="slidenum">
               <a:rPr lang="en-US"/>
               <a:t>13</a:t>
+            </a:fld>
+            <a:endParaRPr lang="en-US"/>
+          </a:p>
+        </p:txBody>
+      </p:sp>
+    </p:spTree>
+    <p:extLst>
+      <p:ext uri="{BB962C8B-B14F-4D97-AF65-F5344CB8AC3E}">
+        <p14:creationId xmlns:p14="http://schemas.microsoft.com/office/powerpoint/2010/main" val="1024086991"/>
+      </p:ext>
+    </p:extLst>
+  </p:cSld>
+  <p:clrMapOvr>
+    <a:masterClrMapping/>
+  </p:clrMapOvr>
+</p:notes>
+</file>
+
+<file path=ppt/notesSlides/notesSlide14.xml><?xml version="1.0" encoding="utf-8"?>
+<p:notes xmlns:a="http://schemas.openxmlformats.org/drawingml/2006/main" xmlns:r="http://schemas.openxmlformats.org/officeDocument/2006/relationships" xmlns:p="http://schemas.openxmlformats.org/presentationml/2006/main">
+  <p:cSld>
+    <p:spTree>
+      <p:nvGrpSpPr>
+        <p:cNvPr id="1" name=""/>
+        <p:cNvGrpSpPr/>
+        <p:nvPr/>
+      </p:nvGrpSpPr>
+      <p:grpSpPr>
+        <a:xfrm>
+          <a:off x="0" y="0"/>
+          <a:ext cx="0" cy="0"/>
+          <a:chOff x="0" y="0"/>
+          <a:chExt cx="0" cy="0"/>
+        </a:xfrm>
+      </p:grpSpPr>
+      <p:sp>
+        <p:nvSpPr>
+          <p:cNvPr id="2" name="Slide Image Placeholder 1"/>
+          <p:cNvSpPr>
+            <a:spLocks noGrp="1" noRot="1" noChangeAspect="1"/>
+          </p:cNvSpPr>
+          <p:nvPr>
+            <p:ph type="sldImg"/>
+          </p:nvPr>
+        </p:nvSpPr>
+        <p:spPr/>
+      </p:sp>
+      <p:sp>
+        <p:nvSpPr>
+          <p:cNvPr id="3" name="Notes Placeholder 2"/>
+          <p:cNvSpPr>
+            <a:spLocks noGrp="1"/>
+          </p:cNvSpPr>
+          <p:nvPr>
+            <p:ph type="body" idx="1"/>
+          </p:nvPr>
+        </p:nvSpPr>
+        <p:spPr/>
+        <p:txBody>
+          <a:bodyPr/>
+          <a:lstStyle/>
+          <a:p>
+            <a:r>
+              <a:rPr lang="en-US" dirty="0"/>
+              <a:t>Cierro con el estado. El sprint cumplió su objetivo: las 26 tareas, y la app instalada desde la prueba interna de Google Play. El Sprint 3 cierra el 24 de octubre con el módulo de muelle sincronizado, las tapas de escotilla, el plan de carga, el BAPLIE de salida, el manual y la presentación final.</a:t>
+            </a:r>
+            <a:endParaRPr lang="en-US" dirty="0"/>
+          </a:p>
+        </p:txBody>
+      </p:sp>
+      <p:sp>
+        <p:nvSpPr>
+          <p:cNvPr id="4" name="Slide Number Placeholder 3"/>
+          <p:cNvSpPr>
+            <a:spLocks noGrp="1"/>
+          </p:cNvSpPr>
+          <p:nvPr>
+            <p:ph type="sldNum" sz="quarter" idx="10"/>
+          </p:nvPr>
+        </p:nvSpPr>
+        <p:spPr/>
+        <p:txBody>
+          <a:bodyPr/>
+          <a:lstStyle/>
+          <a:p>
+            <a:fld id="{F7021451-1387-4CA6-816F-3879F97B5CBC}" type="slidenum">
+              <a:rPr lang="en-US"/>
+              <a:t>14</a:t>
             </a:fld>
             <a:endParaRPr lang="en-US"/>
           </a:p>
@@ -1270,7 +1360,7 @@
           <a:p>
             <a:r>
               <a:rPr lang="en-US" dirty="0"/>
-              <a:t>Los números del sprint. 25 de 26 tareas terminadas, 33 de 35 horas. La tarea abierta es T‑49: la app ya está publicada en la prueba interna de Google Play desde el 3 de octubre, y solo falta comprobar su instalación desde la tienda en el teléfono. La holgura del 34 por ciento se reservó para lo que destapara la verificación con archivos reales, y se usó casi completa en eso.</a:t>
+              <a:t>Los números del sprint. Las 26 tareas terminadas, con sus 35 horas. La última fue T‑49: la app se publicó en la prueba interna de Google Play el 3 de octubre, se instaló en el teléfono desde la tienda y arranca sin conexión. La holgura del 34 por ciento se reservó para lo que destapara la verificación con archivos reales, y se usó casi completa en eso.</a:t>
             </a:r>
             <a:endParaRPr lang="en-US" dirty="0"/>
           </a:p>
@@ -3576,7 +3666,7 @@
                   <a:schemeClr val="tx2"/>
                 </a:solidFill>
               </a:rPr>
-              <a:t>Versión 1 (1.0.0) publicada el 3 de octubre. Falta instalarla en el teléfono desde la tienda.</a:t>
+              <a:t>Versión 1 (1.0.0) publicada el 3 de octubre e instalada en el teléfono desde la tienda. Arranca sin conexión.</a:t>
             </a:r>
             <a:endParaRPr lang="en-US" sz="1350" dirty="0"/>
           </a:p>
@@ -3962,7 +4052,7 @@
                 <a:ea typeface="Cambria" pitchFamily="34" charset="-122"/>
                 <a:cs typeface="Cambria" pitchFamily="34" charset="-120"/>
               </a:rPr>
-              <a:t>Retrospectiva</a:t>
+              <a:t>Prueba de campo con una operación real</a:t>
             </a:r>
             <a:endParaRPr lang="en-US" sz="3000" dirty="0"/>
           </a:p>
@@ -4003,7 +4093,7 @@
                 <a:ea typeface="Calibri" pitchFamily="34" charset="-122"/>
                 <a:cs typeface="Calibri" pitchFamily="34" charset="-120"/>
               </a:rPr>
-              <a:t>Qué conviene conservar, qué no funcionó y qué cambia para el siguiente sprint.</a:t>
+              <a:t>Primera vez con los archivos de una escala real: cuatro defectos y el procedimiento de muelle documentado.</a:t>
             </a:r>
             <a:endParaRPr lang="en-US" sz="1400" dirty="0"/>
           </a:p>
@@ -4111,14 +4201,14 @@
       </p:sp>
       <p:sp>
         <p:nvSpPr>
-          <p:cNvPr id="9" name="retro-1"/>
+          <p:cNvPr id="9" name="defecto-1"/>
           <p:cNvSpPr/>
           <p:nvPr/>
         </p:nvSpPr>
         <p:spPr>
           <a:xfrm>
             <a:off x="640080" y="2011680"/>
-            <a:ext cx="3483864" cy="3246120"/>
+            <a:ext cx="3291840" cy="1600200"/>
           </a:xfrm>
           <a:prstGeom prst="rect">
             <a:avLst/>
@@ -4136,34 +4226,14 @@
       </p:sp>
       <p:sp>
         <p:nvSpPr>
-          <p:cNvPr id="10" name="retro-1-marca"/>
-          <p:cNvSpPr/>
-          <p:nvPr/>
-        </p:nvSpPr>
-        <p:spPr>
-          <a:xfrm>
-            <a:off x="868680" y="2258568"/>
-            <a:ext cx="201168" cy="201168"/>
-          </a:xfrm>
-          <a:prstGeom prst="ellipse">
-            <a:avLst/>
-          </a:prstGeom>
-          <a:solidFill>
-            <a:schemeClr val="accent2"/>
-          </a:solidFill>
-          <a:ln/>
-        </p:spPr>
-      </p:sp>
-      <p:sp>
-        <p:nvSpPr>
-          <p:cNvPr id="11" name="retro-1-titulo"/>
+          <p:cNvPr id="10" name="defecto-1-numero"/>
           <p:cNvSpPr txBox="1"/>
           <p:nvPr/>
         </p:nvSpPr>
         <p:spPr>
           <a:xfrm>
-            <a:off x="1188720" y="2176272"/>
-            <a:ext cx="2706624" cy="365760"/>
+            <a:off x="822960" y="2148840"/>
+            <a:ext cx="365760" cy="411480"/>
           </a:xfrm>
           <a:prstGeom prst="rect">
             <a:avLst/>
@@ -4179,30 +4249,66 @@
               <a:buNone/>
             </a:pPr>
             <a:r>
-              <a:rPr lang="en-US" sz="1800" b="1" dirty="0">
-                <a:solidFill>
-                  <a:schemeClr val="tx1"/>
+              <a:rPr lang="en-US" sz="2400" b="1" dirty="0">
+                <a:solidFill>
+                  <a:schemeClr val="accent1"/>
                 </a:solidFill>
                 <a:latin typeface="Cambria" pitchFamily="34" charset="0"/>
                 <a:ea typeface="Cambria" pitchFamily="34" charset="-122"/>
                 <a:cs typeface="Cambria" pitchFamily="34" charset="-120"/>
               </a:rPr>
-              <a:t>Conservar</a:t>
+              <a:t>1</a:t>
             </a:r>
-            <a:endParaRPr lang="en-US" sz="1800" dirty="0"/>
-          </a:p>
-        </p:txBody>
-      </p:sp>
-      <p:sp>
-        <p:nvSpPr>
-          <p:cNvPr id="12" name="retro-1-lista"/>
+            <a:endParaRPr lang="en-US" sz="2400" dirty="0"/>
+          </a:p>
+        </p:txBody>
+      </p:sp>
+      <p:sp>
+        <p:nvSpPr>
+          <p:cNvPr id="11" name="defecto-1-nombre"/>
           <p:cNvSpPr txBox="1"/>
           <p:nvPr/>
         </p:nvSpPr>
         <p:spPr>
           <a:xfrm>
-            <a:off x="822960" y="2697480"/>
-            <a:ext cx="3118104" cy="2377440"/>
+            <a:off x="1234440" y="2176272"/>
+            <a:ext cx="2514600" cy="365760"/>
+          </a:xfrm>
+          <a:prstGeom prst="rect">
+            <a:avLst/>
+          </a:prstGeom>
+          <a:noFill/>
+          <a:ln/>
+        </p:spPr>
+        <p:txBody>
+          <a:bodyPr wrap="square" lIns="0" tIns="0" rIns="0" bIns="0" rtlCol="0" anchor="ctr"/>
+          <a:lstStyle/>
+          <a:p>
+            <a:pPr indent="0" marL="0">
+              <a:buNone/>
+            </a:pPr>
+            <a:r>
+              <a:rPr lang="en-US" sz="1400" b="1" dirty="0">
+                <a:solidFill>
+                  <a:schemeClr val="tx1"/>
+                </a:solidFill>
+              </a:rPr>
+              <a:t>Pesos solo como VGM</a:t>
+            </a:r>
+            <a:endParaRPr lang="en-US" sz="1400" dirty="0"/>
+          </a:p>
+        </p:txBody>
+      </p:sp>
+      <p:sp>
+        <p:nvSpPr>
+          <p:cNvPr id="12" name="defecto-1-texto"/>
+          <p:cNvSpPr txBox="1"/>
+          <p:nvPr/>
+        </p:nvSpPr>
+        <p:spPr>
+          <a:xfrm>
+            <a:off x="822960" y="2651760"/>
+            <a:ext cx="2926080" cy="822960"/>
           </a:xfrm>
           <a:prstGeom prst="rect">
             <a:avLst/>
@@ -4214,89 +4320,31 @@
           <a:bodyPr wrap="square" lIns="0" tIns="0" rIns="0" bIns="0" rtlCol="0" anchor="t"/>
           <a:lstStyle/>
           <a:p>
-            <a:pPr marL="342900" indent="-342900">
-              <a:spcAft>
-                <a:spcPts val="1000"/>
-              </a:spcAft>
-              <a:buSzPct val="100000"/>
-              <a:buChar char="•"/>
+            <a:pPr indent="0" marL="0">
+              <a:buNone/>
             </a:pPr>
             <a:r>
-              <a:rPr lang="en-US" sz="1350" dirty="0">
-                <a:solidFill>
-                  <a:schemeClr val="tx1"/>
+              <a:rPr lang="en-US" sz="1250" dirty="0">
+                <a:solidFill>
+                  <a:schemeClr val="tx2"/>
                 </a:solidFill>
               </a:rPr>
-              <a:t>Holgura amplia: absorbió 17 h de trabajo no planificado</a:t>
+              <a:t>333 de 398 contenedores sin peso visible y los totales por bahía en cero.</a:t>
             </a:r>
-            <a:endParaRPr lang="en-US" sz="1350" dirty="0"/>
-          </a:p>
-          <a:p>
-            <a:pPr marL="342900" indent="-342900">
-              <a:spcAft>
-                <a:spcPts val="1000"/>
-              </a:spcAft>
-              <a:buSzPct val="100000"/>
-              <a:buChar char="•"/>
-            </a:pPr>
-            <a:r>
-              <a:rPr lang="en-US" sz="1350" dirty="0">
-                <a:solidFill>
-                  <a:schemeClr val="tx1"/>
-                </a:solidFill>
-              </a:rPr>
-              <a:t>Identificar cada binario por su resumen SHA‑256</a:t>
-            </a:r>
-            <a:endParaRPr lang="en-US" sz="1350" dirty="0"/>
-          </a:p>
-          <a:p>
-            <a:pPr marL="342900" indent="-342900">
-              <a:spcAft>
-                <a:spcPts val="1000"/>
-              </a:spcAft>
-              <a:buSzPct val="100000"/>
-              <a:buChar char="•"/>
-            </a:pPr>
-            <a:r>
-              <a:rPr lang="en-US" sz="1350" dirty="0">
-                <a:solidFill>
-                  <a:schemeClr val="tx1"/>
-                </a:solidFill>
-              </a:rPr>
-              <a:t>Dos programadores en paralelo, con reglas escritas</a:t>
-            </a:r>
-            <a:endParaRPr lang="en-US" sz="1350" dirty="0"/>
-          </a:p>
-          <a:p>
-            <a:pPr marL="342900" indent="-342900">
-              <a:spcAft>
-                <a:spcPts val="1000"/>
-              </a:spcAft>
-              <a:buSzPct val="100000"/>
-              <a:buChar char="•"/>
-            </a:pPr>
-            <a:r>
-              <a:rPr lang="en-US" sz="1350" dirty="0">
-                <a:solidFill>
-                  <a:schemeClr val="tx1"/>
-                </a:solidFill>
-              </a:rPr>
-              <a:t>La doble prueba: 9 casos en que una segunda revisión encontró un error</a:t>
-            </a:r>
-            <a:endParaRPr lang="en-US" sz="1350" dirty="0"/>
-          </a:p>
-        </p:txBody>
-      </p:sp>
-      <p:sp>
-        <p:nvSpPr>
-          <p:cNvPr id="13" name="retro-2"/>
+            <a:endParaRPr lang="en-US" sz="1250" dirty="0"/>
+          </a:p>
+        </p:txBody>
+      </p:sp>
+      <p:sp>
+        <p:nvSpPr>
+          <p:cNvPr id="13" name="defecto-2"/>
           <p:cNvSpPr/>
           <p:nvPr/>
         </p:nvSpPr>
         <p:spPr>
           <a:xfrm>
-            <a:off x="4352544" y="2011680"/>
-            <a:ext cx="3483864" cy="3246120"/>
+            <a:off x="4114800" y="2011680"/>
+            <a:ext cx="3291840" cy="1600200"/>
           </a:xfrm>
           <a:prstGeom prst="rect">
             <a:avLst/>
@@ -4314,34 +4362,14 @@
       </p:sp>
       <p:sp>
         <p:nvSpPr>
-          <p:cNvPr id="14" name="retro-2-marca"/>
-          <p:cNvSpPr/>
-          <p:nvPr/>
-        </p:nvSpPr>
-        <p:spPr>
-          <a:xfrm>
-            <a:off x="4581144" y="2258568"/>
-            <a:ext cx="201168" cy="201168"/>
-          </a:xfrm>
-          <a:prstGeom prst="ellipse">
-            <a:avLst/>
-          </a:prstGeom>
-          <a:solidFill>
-            <a:schemeClr val="accent3"/>
-          </a:solidFill>
-          <a:ln/>
-        </p:spPr>
-      </p:sp>
-      <p:sp>
-        <p:nvSpPr>
-          <p:cNvPr id="15" name="retro-2-titulo"/>
+          <p:cNvPr id="14" name="defecto-2-numero"/>
           <p:cNvSpPr txBox="1"/>
           <p:nvPr/>
         </p:nvSpPr>
         <p:spPr>
           <a:xfrm>
-            <a:off x="4901184" y="2176272"/>
-            <a:ext cx="2706624" cy="365760"/>
+            <a:off x="4297680" y="2148840"/>
+            <a:ext cx="365760" cy="411480"/>
           </a:xfrm>
           <a:prstGeom prst="rect">
             <a:avLst/>
@@ -4357,30 +4385,66 @@
               <a:buNone/>
             </a:pPr>
             <a:r>
-              <a:rPr lang="en-US" sz="1800" b="1" dirty="0">
-                <a:solidFill>
-                  <a:schemeClr val="tx1"/>
+              <a:rPr lang="en-US" sz="2400" b="1" dirty="0">
+                <a:solidFill>
+                  <a:schemeClr val="accent1"/>
                 </a:solidFill>
                 <a:latin typeface="Cambria" pitchFamily="34" charset="0"/>
                 <a:ea typeface="Cambria" pitchFamily="34" charset="-122"/>
                 <a:cs typeface="Cambria" pitchFamily="34" charset="-120"/>
               </a:rPr>
-              <a:t>No funcionó</a:t>
+              <a:t>2</a:t>
             </a:r>
-            <a:endParaRPr lang="en-US" sz="1800" dirty="0"/>
-          </a:p>
-        </p:txBody>
-      </p:sp>
-      <p:sp>
-        <p:nvSpPr>
-          <p:cNvPr id="16" name="retro-2-lista"/>
+            <a:endParaRPr lang="en-US" sz="2400" dirty="0"/>
+          </a:p>
+        </p:txBody>
+      </p:sp>
+      <p:sp>
+        <p:nvSpPr>
+          <p:cNvPr id="15" name="defecto-2-nombre"/>
           <p:cNvSpPr txBox="1"/>
           <p:nvPr/>
         </p:nvSpPr>
         <p:spPr>
           <a:xfrm>
-            <a:off x="4535424" y="2697480"/>
-            <a:ext cx="3118104" cy="2377440"/>
+            <a:off x="4709160" y="2176272"/>
+            <a:ext cx="2514600" cy="365760"/>
+          </a:xfrm>
+          <a:prstGeom prst="rect">
+            <a:avLst/>
+          </a:prstGeom>
+          <a:noFill/>
+          <a:ln/>
+        </p:spPr>
+        <p:txBody>
+          <a:bodyPr wrap="square" lIns="0" tIns="0" rIns="0" bIns="0" rtlCol="0" anchor="ctr"/>
+          <a:lstStyle/>
+          <a:p>
+            <a:pPr indent="0" marL="0">
+              <a:buNone/>
+            </a:pPr>
+            <a:r>
+              <a:rPr lang="en-US" sz="1400" b="1" dirty="0">
+                <a:solidFill>
+                  <a:schemeClr val="tx1"/>
+                </a:solidFill>
+              </a:rPr>
+              <a:t>Peso por pila</a:t>
+            </a:r>
+            <a:endParaRPr lang="en-US" sz="1400" dirty="0"/>
+          </a:p>
+        </p:txBody>
+      </p:sp>
+      <p:sp>
+        <p:nvSpPr>
+          <p:cNvPr id="16" name="defecto-2-texto"/>
+          <p:cNvSpPr txBox="1"/>
+          <p:nvPr/>
+        </p:nvSpPr>
+        <p:spPr>
+          <a:xfrm>
+            <a:off x="4297680" y="2651760"/>
+            <a:ext cx="2926080" cy="822960"/>
           </a:xfrm>
           <a:prstGeom prst="rect">
             <a:avLst/>
@@ -4392,89 +4456,31 @@
           <a:bodyPr wrap="square" lIns="0" tIns="0" rIns="0" bIns="0" rtlCol="0" anchor="t"/>
           <a:lstStyle/>
           <a:p>
-            <a:pPr marL="342900" indent="-342900">
-              <a:spcAft>
-                <a:spcPts val="1000"/>
-              </a:spcAft>
-              <a:buSzPct val="100000"/>
-              <a:buChar char="•"/>
+            <a:pPr indent="0" marL="0">
+              <a:buNone/>
             </a:pPr>
             <a:r>
-              <a:rPr lang="en-US" sz="1350" dirty="0">
-                <a:solidFill>
-                  <a:schemeClr val="tx1"/>
+              <a:rPr lang="en-US" sz="1250" dirty="0">
+                <a:solidFill>
+                  <a:schemeClr val="tx2"/>
                 </a:solidFill>
               </a:rPr>
-              <a:t>Los trámites externos empezaron el día 13, no el primero</a:t>
+              <a:t>Un contenedor sin peso cuenta como cero: la regla calla en vez de declararse no evaluada.</a:t>
             </a:r>
-            <a:endParaRPr lang="en-US" sz="1350" dirty="0"/>
-          </a:p>
-          <a:p>
-            <a:pPr marL="342900" indent="-342900">
-              <a:spcAft>
-                <a:spcPts val="1000"/>
-              </a:spcAft>
-              <a:buSzPct val="100000"/>
-              <a:buChar char="•"/>
-            </a:pPr>
-            <a:r>
-              <a:rPr lang="en-US" sz="1350" dirty="0">
-                <a:solidFill>
-                  <a:schemeClr val="tx1"/>
-                </a:solidFill>
-              </a:rPr>
-              <a:t>Las alertas automáticas, sin facturación</a:t>
-            </a:r>
-            <a:endParaRPr lang="en-US" sz="1350" dirty="0"/>
-          </a:p>
-          <a:p>
-            <a:pPr marL="342900" indent="-342900">
-              <a:spcAft>
-                <a:spcPts val="1000"/>
-              </a:spcAft>
-              <a:buSzPct val="100000"/>
-              <a:buChar char="•"/>
-            </a:pPr>
-            <a:r>
-              <a:rPr lang="en-US" sz="1350" dirty="0">
-                <a:solidFill>
-                  <a:schemeClr val="tx1"/>
-                </a:solidFill>
-              </a:rPr>
-              <a:t>La Web sin conexión</a:t>
-            </a:r>
-            <a:endParaRPr lang="en-US" sz="1350" dirty="0"/>
-          </a:p>
-          <a:p>
-            <a:pPr marL="342900" indent="-342900">
-              <a:spcAft>
-                <a:spcPts val="1000"/>
-              </a:spcAft>
-              <a:buSzPct val="100000"/>
-              <a:buChar char="•"/>
-            </a:pPr>
-            <a:r>
-              <a:rPr lang="en-US" sz="1350" dirty="0">
-                <a:solidFill>
-                  <a:schemeClr val="tx1"/>
-                </a:solidFill>
-              </a:rPr>
-              <a:t>Requerimientos no funcionales no verificables tal como se escribieron</a:t>
-            </a:r>
-            <a:endParaRPr lang="en-US" sz="1350" dirty="0"/>
-          </a:p>
-        </p:txBody>
-      </p:sp>
-      <p:sp>
-        <p:nvSpPr>
-          <p:cNvPr id="17" name="retro-3"/>
+            <a:endParaRPr lang="en-US" sz="1250" dirty="0"/>
+          </a:p>
+        </p:txBody>
+      </p:sp>
+      <p:sp>
+        <p:nvSpPr>
+          <p:cNvPr id="17" name="defecto-3"/>
           <p:cNvSpPr/>
           <p:nvPr/>
         </p:nvSpPr>
         <p:spPr>
           <a:xfrm>
-            <a:off x="8065008" y="2011680"/>
-            <a:ext cx="3483864" cy="3246120"/>
+            <a:off x="640080" y="3794760"/>
+            <a:ext cx="3291840" cy="1600200"/>
           </a:xfrm>
           <a:prstGeom prst="rect">
             <a:avLst/>
@@ -4492,34 +4498,14 @@
       </p:sp>
       <p:sp>
         <p:nvSpPr>
-          <p:cNvPr id="18" name="retro-3-marca"/>
-          <p:cNvSpPr/>
-          <p:nvPr/>
-        </p:nvSpPr>
-        <p:spPr>
-          <a:xfrm>
-            <a:off x="8293608" y="2258568"/>
-            <a:ext cx="201168" cy="201168"/>
-          </a:xfrm>
-          <a:prstGeom prst="ellipse">
-            <a:avLst/>
-          </a:prstGeom>
-          <a:solidFill>
-            <a:schemeClr val="accent4"/>
-          </a:solidFill>
-          <a:ln/>
-        </p:spPr>
-      </p:sp>
-      <p:sp>
-        <p:nvSpPr>
-          <p:cNvPr id="19" name="retro-3-titulo"/>
+          <p:cNvPr id="18" name="defecto-3-numero"/>
           <p:cNvSpPr txBox="1"/>
           <p:nvPr/>
         </p:nvSpPr>
         <p:spPr>
           <a:xfrm>
-            <a:off x="8613648" y="2176272"/>
-            <a:ext cx="2706624" cy="365760"/>
+            <a:off x="822960" y="3931920"/>
+            <a:ext cx="365760" cy="411480"/>
           </a:xfrm>
           <a:prstGeom prst="rect">
             <a:avLst/>
@@ -4535,30 +4521,66 @@
               <a:buNone/>
             </a:pPr>
             <a:r>
-              <a:rPr lang="en-US" sz="1800" b="1" dirty="0">
-                <a:solidFill>
-                  <a:schemeClr val="tx1"/>
+              <a:rPr lang="en-US" sz="2400" b="1" dirty="0">
+                <a:solidFill>
+                  <a:schemeClr val="accent1"/>
                 </a:solidFill>
                 <a:latin typeface="Cambria" pitchFamily="34" charset="0"/>
                 <a:ea typeface="Cambria" pitchFamily="34" charset="-122"/>
                 <a:cs typeface="Cambria" pitchFamily="34" charset="-120"/>
               </a:rPr>
-              <a:t>Cambia</a:t>
+              <a:t>3</a:t>
             </a:r>
-            <a:endParaRPr lang="en-US" sz="1800" dirty="0"/>
-          </a:p>
-        </p:txBody>
-      </p:sp>
-      <p:sp>
-        <p:nvSpPr>
-          <p:cNvPr id="20" name="retro-3-lista"/>
+            <a:endParaRPr lang="en-US" sz="2400" dirty="0"/>
+          </a:p>
+        </p:txBody>
+      </p:sp>
+      <p:sp>
+        <p:nvSpPr>
+          <p:cNvPr id="19" name="defecto-3-nombre"/>
           <p:cNvSpPr txBox="1"/>
           <p:nvPr/>
         </p:nvSpPr>
         <p:spPr>
           <a:xfrm>
-            <a:off x="8247888" y="2697480"/>
-            <a:ext cx="3118104" cy="2377440"/>
+            <a:off x="1234440" y="3959352"/>
+            <a:ext cx="2514600" cy="365760"/>
+          </a:xfrm>
+          <a:prstGeom prst="rect">
+            <a:avLst/>
+          </a:prstGeom>
+          <a:noFill/>
+          <a:ln/>
+        </p:spPr>
+        <p:txBody>
+          <a:bodyPr wrap="square" lIns="0" tIns="0" rIns="0" bIns="0" rtlCol="0" anchor="ctr"/>
+          <a:lstStyle/>
+          <a:p>
+            <a:pPr indent="0" marL="0">
+              <a:buNone/>
+            </a:pPr>
+            <a:r>
+              <a:rPr lang="en-US" sz="1400" b="1" dirty="0">
+                <a:solidFill>
+                  <a:schemeClr val="tx1"/>
+                </a:solidFill>
+              </a:rPr>
+              <a:t>Puerto de escala en llegada</a:t>
+            </a:r>
+            <a:endParaRPr lang="en-US" sz="1400" dirty="0"/>
+          </a:p>
+        </p:txBody>
+      </p:sp>
+      <p:sp>
+        <p:nvSpPr>
+          <p:cNvPr id="20" name="defecto-3-texto"/>
+          <p:cNvSpPr txBox="1"/>
+          <p:nvPr/>
+        </p:nvSpPr>
+        <p:spPr>
+          <a:xfrm>
+            <a:off x="822960" y="4434840"/>
+            <a:ext cx="2926080" cy="822960"/>
           </a:xfrm>
           <a:prstGeom prst="rect">
             <a:avLst/>
@@ -4570,88 +4592,302 @@
           <a:bodyPr wrap="square" lIns="0" tIns="0" rIns="0" bIns="0" rtlCol="0" anchor="t"/>
           <a:lstStyle/>
           <a:p>
-            <a:pPr marL="342900" indent="-342900">
-              <a:spcAft>
-                <a:spcPts val="1000"/>
-              </a:spcAft>
-              <a:buSzPct val="100000"/>
-              <a:buChar char="•"/>
+            <a:pPr indent="0" marL="0">
+              <a:buNone/>
             </a:pPr>
             <a:r>
-              <a:rPr lang="en-US" sz="1350" dirty="0">
-                <a:solidFill>
-                  <a:schemeClr val="tx1"/>
+              <a:rPr lang="en-US" sz="1250" dirty="0">
+                <a:solidFill>
+                  <a:schemeClr val="tx2"/>
                 </a:solidFill>
               </a:rPr>
-              <a:t>Decidir al planificar qué RNF se miden</a:t>
+              <a:t>Se proponía desde el puerto de salida: los 114 contenedores a descargar salían como de paso.</a:t>
             </a:r>
-            <a:endParaRPr lang="en-US" sz="1350" dirty="0"/>
-          </a:p>
-          <a:p>
-            <a:pPr marL="342900" indent="-342900">
-              <a:spcAft>
-                <a:spcPts val="1000"/>
-              </a:spcAft>
-              <a:buSzPct val="100000"/>
-              <a:buChar char="•"/>
+            <a:endParaRPr lang="en-US" sz="1250" dirty="0"/>
+          </a:p>
+        </p:txBody>
+      </p:sp>
+      <p:sp>
+        <p:nvSpPr>
+          <p:cNvPr id="21" name="defecto-4"/>
+          <p:cNvSpPr/>
+          <p:nvPr/>
+        </p:nvSpPr>
+        <p:spPr>
+          <a:xfrm>
+            <a:off x="4114800" y="3794760"/>
+            <a:ext cx="3291840" cy="1600200"/>
+          </a:xfrm>
+          <a:prstGeom prst="rect">
+            <a:avLst/>
+          </a:prstGeom>
+          <a:solidFill>
+            <a:schemeClr val="bg2"/>
+          </a:solidFill>
+          <a:ln w="9525">
+            <a:solidFill>
+              <a:srgbClr val="D6D2CB"/>
+            </a:solidFill>
+            <a:prstDash val="solid"/>
+          </a:ln>
+        </p:spPr>
+      </p:sp>
+      <p:sp>
+        <p:nvSpPr>
+          <p:cNvPr id="22" name="defecto-4-numero"/>
+          <p:cNvSpPr txBox="1"/>
+          <p:nvPr/>
+        </p:nvSpPr>
+        <p:spPr>
+          <a:xfrm>
+            <a:off x="4297680" y="3931920"/>
+            <a:ext cx="365760" cy="411480"/>
+          </a:xfrm>
+          <a:prstGeom prst="rect">
+            <a:avLst/>
+          </a:prstGeom>
+          <a:noFill/>
+          <a:ln/>
+        </p:spPr>
+        <p:txBody>
+          <a:bodyPr wrap="square" lIns="0" tIns="0" rIns="0" bIns="0" rtlCol="0" anchor="ctr"/>
+          <a:lstStyle/>
+          <a:p>
+            <a:pPr indent="0" marL="0">
+              <a:buNone/>
             </a:pPr>
             <a:r>
-              <a:rPr lang="en-US" sz="1350" dirty="0">
-                <a:solidFill>
-                  <a:schemeClr val="tx1"/>
-                </a:solidFill>
+              <a:rPr lang="en-US" sz="2400" b="1" dirty="0">
+                <a:solidFill>
+                  <a:schemeClr val="accent1"/>
+                </a:solidFill>
+                <a:latin typeface="Cambria" pitchFamily="34" charset="0"/>
+                <a:ea typeface="Cambria" pitchFamily="34" charset="-122"/>
+                <a:cs typeface="Cambria" pitchFamily="34" charset="-120"/>
               </a:rPr>
-              <a:t>Abrir la prueba cerrada en cuanto exista la interna, con 12 testers listos</a:t>
+              <a:t>4</a:t>
             </a:r>
-            <a:endParaRPr lang="en-US" sz="1350" dirty="0"/>
-          </a:p>
-          <a:p>
-            <a:pPr marL="342900" indent="-342900">
-              <a:spcAft>
-                <a:spcPts val="1000"/>
-              </a:spcAft>
-              <a:buSzPct val="100000"/>
-              <a:buChar char="•"/>
+            <a:endParaRPr lang="en-US" sz="2400" dirty="0"/>
+          </a:p>
+        </p:txBody>
+      </p:sp>
+      <p:sp>
+        <p:nvSpPr>
+          <p:cNvPr id="23" name="defecto-4-nombre"/>
+          <p:cNvSpPr txBox="1"/>
+          <p:nvPr/>
+        </p:nvSpPr>
+        <p:spPr>
+          <a:xfrm>
+            <a:off x="4709160" y="3959352"/>
+            <a:ext cx="2514600" cy="365760"/>
+          </a:xfrm>
+          <a:prstGeom prst="rect">
+            <a:avLst/>
+          </a:prstGeom>
+          <a:noFill/>
+          <a:ln/>
+        </p:spPr>
+        <p:txBody>
+          <a:bodyPr wrap="square" lIns="0" tIns="0" rIns="0" bIns="0" rtlCol="0" anchor="ctr"/>
+          <a:lstStyle/>
+          <a:p>
+            <a:pPr indent="0" marL="0">
+              <a:buNone/>
             </a:pPr>
             <a:r>
-              <a:rPr lang="en-US" sz="1350" dirty="0">
+              <a:rPr lang="en-US" sz="1400" b="1" dirty="0">
                 <a:solidFill>
                   <a:schemeClr val="tx1"/>
                 </a:solidFill>
               </a:rPr>
-              <a:t>Política de privacidad en la app, ícono propio y respaldo automático</a:t>
+              <a:t>Celdas reservadas</a:t>
             </a:r>
-            <a:endParaRPr lang="en-US" sz="1350" dirty="0"/>
-          </a:p>
-          <a:p>
-            <a:pPr marL="342900" indent="-342900">
-              <a:spcAft>
-                <a:spcPts val="1000"/>
-              </a:spcAft>
-              <a:buSzPct val="100000"/>
-              <a:buChar char="•"/>
+            <a:endParaRPr lang="en-US" sz="1400" dirty="0"/>
+          </a:p>
+        </p:txBody>
+      </p:sp>
+      <p:sp>
+        <p:nvSpPr>
+          <p:cNvPr id="24" name="defecto-4-texto"/>
+          <p:cNvSpPr txBox="1"/>
+          <p:nvPr/>
+        </p:nvSpPr>
+        <p:spPr>
+          <a:xfrm>
+            <a:off x="4297680" y="4434840"/>
+            <a:ext cx="2926080" cy="822960"/>
+          </a:xfrm>
+          <a:prstGeom prst="rect">
+            <a:avLst/>
+          </a:prstGeom>
+          <a:noFill/>
+          <a:ln/>
+        </p:spPr>
+        <p:txBody>
+          <a:bodyPr wrap="square" lIns="0" tIns="0" rIns="0" bIns="0" rtlCol="0" anchor="t"/>
+          <a:lstStyle/>
+          <a:p>
+            <a:pPr indent="0" marL="0">
+              <a:buNone/>
             </a:pPr>
             <a:r>
-              <a:rPr lang="en-US" sz="1350" dirty="0">
+              <a:rPr lang="en-US" sz="1250" dirty="0">
+                <a:solidFill>
+                  <a:schemeClr val="tx2"/>
+                </a:solidFill>
+              </a:rPr>
+              <a:t>Los 55 vacíos aún sin número desaparecían: la app mostraba 405 de 460 posiciones.</a:t>
+            </a:r>
+            <a:endParaRPr lang="en-US" sz="1250" dirty="0"/>
+          </a:p>
+        </p:txBody>
+      </p:sp>
+      <p:sp>
+        <p:nvSpPr>
+          <p:cNvPr id="25" name="escala"/>
+          <p:cNvSpPr/>
+          <p:nvPr/>
+        </p:nvSpPr>
+        <p:spPr>
+          <a:xfrm>
+            <a:off x="7726680" y="2011680"/>
+            <a:ext cx="3822192" cy="3383280"/>
+          </a:xfrm>
+          <a:prstGeom prst="rect">
+            <a:avLst/>
+          </a:prstGeom>
+          <a:solidFill>
+            <a:schemeClr val="bg2"/>
+          </a:solidFill>
+          <a:ln w="9525">
+            <a:solidFill>
+              <a:srgbClr val="D6D2CB"/>
+            </a:solidFill>
+            <a:prstDash val="solid"/>
+          </a:ln>
+        </p:spPr>
+      </p:sp>
+      <p:sp>
+        <p:nvSpPr>
+          <p:cNvPr id="26" name="escala-cifra"/>
+          <p:cNvSpPr txBox="1"/>
+          <p:nvPr/>
+        </p:nvSpPr>
+        <p:spPr>
+          <a:xfrm>
+            <a:off x="8001000" y="2194560"/>
+            <a:ext cx="3273552" cy="731520"/>
+          </a:xfrm>
+          <a:prstGeom prst="rect">
+            <a:avLst/>
+          </a:prstGeom>
+          <a:noFill/>
+          <a:ln/>
+        </p:spPr>
+        <p:txBody>
+          <a:bodyPr wrap="square" lIns="0" tIns="0" rIns="0" bIns="0" rtlCol="0" anchor="ctr"/>
+          <a:lstStyle/>
+          <a:p>
+            <a:pPr indent="0" marL="0">
+              <a:buNone/>
+            </a:pPr>
+            <a:r>
+              <a:rPr lang="en-US" sz="4000" b="1" dirty="0">
+                <a:solidFill>
+                  <a:schemeClr val="accent2"/>
+                </a:solidFill>
+                <a:latin typeface="Cambria" pitchFamily="34" charset="0"/>
+                <a:ea typeface="Cambria" pitchFamily="34" charset="-122"/>
+                <a:cs typeface="Cambria" pitchFamily="34" charset="-120"/>
+              </a:rPr>
+              <a:t>176</a:t>
+            </a:r>
+            <a:endParaRPr lang="en-US" sz="4000" dirty="0"/>
+          </a:p>
+        </p:txBody>
+      </p:sp>
+      <p:sp>
+        <p:nvSpPr>
+          <p:cNvPr id="27" name="escala-rotulo"/>
+          <p:cNvSpPr txBox="1"/>
+          <p:nvPr/>
+        </p:nvSpPr>
+        <p:spPr>
+          <a:xfrm>
+            <a:off x="8001000" y="2926080"/>
+            <a:ext cx="3273552" cy="320040"/>
+          </a:xfrm>
+          <a:prstGeom prst="rect">
+            <a:avLst/>
+          </a:prstGeom>
+          <a:noFill/>
+          <a:ln/>
+        </p:spPr>
+        <p:txBody>
+          <a:bodyPr wrap="square" lIns="0" tIns="0" rIns="0" bIns="0" rtlCol="0" anchor="ctr"/>
+          <a:lstStyle/>
+          <a:p>
+            <a:pPr indent="0" marL="0">
+              <a:buNone/>
+            </a:pPr>
+            <a:r>
+              <a:rPr lang="en-US" sz="1300" b="1" dirty="0">
                 <a:solidFill>
                   <a:schemeClr val="tx1"/>
                 </a:solidFill>
               </a:rPr>
-              <a:t>Convertir en requerimiento el módulo de muelle (CU04 y CU10)</a:t>
+              <a:t>movimientos de carga que cuadran</a:t>
             </a:r>
-            <a:endParaRPr lang="en-US" sz="1350" dirty="0"/>
-          </a:p>
-        </p:txBody>
-      </p:sp>
-      <p:sp>
-        <p:nvSpPr>
-          <p:cNvPr id="21" name="retro-cierre"/>
+            <a:endParaRPr lang="en-US" sz="1300" dirty="0"/>
+          </a:p>
+        </p:txBody>
+      </p:sp>
+      <p:sp>
+        <p:nvSpPr>
+          <p:cNvPr id="28" name="escala-texto"/>
           <p:cNvSpPr txBox="1"/>
           <p:nvPr/>
         </p:nvSpPr>
         <p:spPr>
           <a:xfrm>
-            <a:off x="640080" y="5440680"/>
+            <a:off x="8001000" y="3337560"/>
+            <a:ext cx="3273552" cy="1920240"/>
+          </a:xfrm>
+          <a:prstGeom prst="rect">
+            <a:avLst/>
+          </a:prstGeom>
+          <a:noFill/>
+          <a:ln/>
+        </p:spPr>
+        <p:txBody>
+          <a:bodyPr wrap="square" lIns="0" tIns="0" rIns="0" bIns="0" rtlCol="0" anchor="t"/>
+          <a:lstStyle/>
+          <a:p>
+            <a:pPr indent="0" marL="0">
+              <a:buNone/>
+            </a:pPr>
+            <a:r>
+              <a:rPr lang="en-US" sz="1250" dirty="0">
+                <a:solidFill>
+                  <a:schemeClr val="tx2"/>
+                </a:solidFill>
+              </a:rPr>
+              <a:t>El listado de exportación, el plan del planificador y el plano anotado a mano coinciden: 120 llenos con su posición y 56 vacíos en celdas reservadas por tipo, puerto y línea. Ese registro en papel es lo que reemplaza el módulo de muelle de H3, y la escala será su prueba de aceptación.</a:t>
+            </a:r>
+            <a:endParaRPr lang="en-US" sz="1250" dirty="0"/>
+          </a:p>
+        </p:txBody>
+      </p:sp>
+      <p:sp>
+        <p:nvSpPr>
+          <p:cNvPr id="29" name="campo-cierre"/>
+          <p:cNvSpPr txBox="1"/>
+          <p:nvPr/>
+        </p:nvSpPr>
+        <p:spPr>
+          <a:xfrm>
+            <a:off x="640080" y="5486400"/>
             <a:ext cx="10908792" cy="457200"/>
           </a:xfrm>
           <a:prstGeom prst="rect">
@@ -4673,7 +4909,7 @@
                   <a:schemeClr val="tx2"/>
                 </a:solidFill>
               </a:rPr>
-              <a:t>Tres de los nueve errores de la doble prueba eran de quien planificaba y auditaba, y uno del propio autor: la verificación no distingue roles.</a:t>
+              <a:t>Tres de los cuatro se podían reproducir con el corpus: la aceptación miraba las reglas, no lo que el planificador lee en pantalla. Los cuatro abren el Sprint 3.</a:t>
             </a:r>
             <a:endParaRPr lang="en-US" sz="1250" dirty="0"/>
           </a:p>
@@ -4784,7 +5020,7 @@
                 <a:ea typeface="Cambria" pitchFamily="34" charset="-122"/>
                 <a:cs typeface="Cambria" pitchFamily="34" charset="-120"/>
               </a:rPr>
-              <a:t>Lo que el incremento implica para las hipótesis</a:t>
+              <a:t>Retrospectiva</a:t>
             </a:r>
             <a:endParaRPr lang="en-US" sz="3000" dirty="0"/>
           </a:p>
@@ -4825,7 +5061,7 @@
                 <a:ea typeface="Calibri" pitchFamily="34" charset="-122"/>
                 <a:cs typeface="Calibri" pitchFamily="34" charset="-120"/>
               </a:rPr>
-              <a:t>Ningún indicador se mide todavía, y H3 espera un módulo que ningún requerimiento recogió.</a:t>
+              <a:t>Qué conviene conservar, qué no funcionó y qué cambia para el siguiente sprint.</a:t>
             </a:r>
             <a:endParaRPr lang="en-US" sz="1400" dirty="0"/>
           </a:p>
@@ -4933,14 +5169,14 @@
       </p:sp>
       <p:sp>
         <p:nvSpPr>
-          <p:cNvPr id="9" name="hipotesis-1"/>
+          <p:cNvPr id="9" name="retro-1"/>
           <p:cNvSpPr/>
           <p:nvPr/>
         </p:nvSpPr>
         <p:spPr>
           <a:xfrm>
             <a:off x="640080" y="2011680"/>
-            <a:ext cx="3483864" cy="3017520"/>
+            <a:ext cx="3483864" cy="3246120"/>
           </a:xfrm>
           <a:prstGeom prst="rect">
             <a:avLst/>
@@ -4958,14 +5194,34 @@
       </p:sp>
       <p:sp>
         <p:nvSpPr>
-          <p:cNvPr id="10" name="hipotesis-1-codigo"/>
+          <p:cNvPr id="10" name="retro-1-marca"/>
+          <p:cNvSpPr/>
+          <p:nvPr/>
+        </p:nvSpPr>
+        <p:spPr>
+          <a:xfrm>
+            <a:off x="868680" y="2258568"/>
+            <a:ext cx="201168" cy="201168"/>
+          </a:xfrm>
+          <a:prstGeom prst="ellipse">
+            <a:avLst/>
+          </a:prstGeom>
+          <a:solidFill>
+            <a:schemeClr val="accent2"/>
+          </a:solidFill>
+          <a:ln/>
+        </p:spPr>
+      </p:sp>
+      <p:sp>
+        <p:nvSpPr>
+          <p:cNvPr id="11" name="retro-1-titulo"/>
           <p:cNvSpPr txBox="1"/>
           <p:nvPr/>
         </p:nvSpPr>
         <p:spPr>
           <a:xfrm>
-            <a:off x="868680" y="2194560"/>
-            <a:ext cx="1097280" cy="685800"/>
+            <a:off x="1188720" y="2176272"/>
+            <a:ext cx="2706624" cy="365760"/>
           </a:xfrm>
           <a:prstGeom prst="rect">
             <a:avLst/>
@@ -4981,30 +5237,30 @@
               <a:buNone/>
             </a:pPr>
             <a:r>
-              <a:rPr lang="en-US" sz="3600" b="1" dirty="0">
-                <a:solidFill>
-                  <a:schemeClr val="accent1"/>
+              <a:rPr lang="en-US" sz="1800" b="1" dirty="0">
+                <a:solidFill>
+                  <a:schemeClr val="tx1"/>
                 </a:solidFill>
                 <a:latin typeface="Cambria" pitchFamily="34" charset="0"/>
                 <a:ea typeface="Cambria" pitchFamily="34" charset="-122"/>
                 <a:cs typeface="Cambria" pitchFamily="34" charset="-120"/>
               </a:rPr>
-              <a:t>H3</a:t>
+              <a:t>Conservar</a:t>
             </a:r>
-            <a:endParaRPr lang="en-US" sz="3600" dirty="0"/>
-          </a:p>
-        </p:txBody>
-      </p:sp>
-      <p:sp>
-        <p:nvSpPr>
-          <p:cNvPr id="11" name="hipotesis-1-nombre"/>
+            <a:endParaRPr lang="en-US" sz="1800" dirty="0"/>
+          </a:p>
+        </p:txBody>
+      </p:sp>
+      <p:sp>
+        <p:nvSpPr>
+          <p:cNvPr id="12" name="retro-1-lista"/>
           <p:cNvSpPr txBox="1"/>
           <p:nvPr/>
         </p:nvSpPr>
         <p:spPr>
           <a:xfrm>
-            <a:off x="868680" y="2926080"/>
-            <a:ext cx="3026664" cy="411480"/>
+            <a:off x="822960" y="2697480"/>
+            <a:ext cx="3118104" cy="2377440"/>
           </a:xfrm>
           <a:prstGeom prst="rect">
             <a:avLst/>
@@ -5013,70 +5269,92 @@
           <a:ln/>
         </p:spPr>
         <p:txBody>
-          <a:bodyPr wrap="square" lIns="0" tIns="0" rIns="0" bIns="0" rtlCol="0" anchor="ctr"/>
+          <a:bodyPr wrap="square" lIns="0" tIns="0" rIns="0" bIns="0" rtlCol="0" anchor="t"/>
           <a:lstStyle/>
           <a:p>
-            <a:pPr indent="0" marL="0">
-              <a:buNone/>
+            <a:pPr marL="342900" indent="-342900">
+              <a:spcAft>
+                <a:spcPts val="1000"/>
+              </a:spcAft>
+              <a:buSzPct val="100000"/>
+              <a:buChar char="•"/>
             </a:pPr>
             <a:r>
-              <a:rPr lang="en-US" sz="1500" b="1" dirty="0">
+              <a:rPr lang="en-US" sz="1350" dirty="0">
                 <a:solidFill>
                   <a:schemeClr val="tx1"/>
                 </a:solidFill>
               </a:rPr>
-              <a:t>Validación preventiva</a:t>
+              <a:t>Holgura amplia: absorbió 17 h de trabajo no planificado</a:t>
             </a:r>
-            <a:endParaRPr lang="en-US" sz="1500" dirty="0"/>
-          </a:p>
-        </p:txBody>
-      </p:sp>
-      <p:sp>
-        <p:nvSpPr>
-          <p:cNvPr id="12" name="hipotesis-1-texto"/>
-          <p:cNvSpPr txBox="1"/>
-          <p:nvPr/>
-        </p:nvSpPr>
-        <p:spPr>
-          <a:xfrm>
-            <a:off x="868680" y="3429000"/>
-            <a:ext cx="3026664" cy="2011680"/>
-          </a:xfrm>
-          <a:prstGeom prst="rect">
-            <a:avLst/>
-          </a:prstGeom>
-          <a:noFill/>
-          <a:ln/>
-        </p:spPr>
-        <p:txBody>
-          <a:bodyPr wrap="square" lIns="0" tIns="0" rIns="0" bIns="0" rtlCol="0" anchor="t"/>
-          <a:lstStyle/>
-          <a:p>
-            <a:pPr indent="0" marL="0">
-              <a:buNone/>
+            <a:endParaRPr lang="en-US" sz="1350" dirty="0"/>
+          </a:p>
+          <a:p>
+            <a:pPr marL="342900" indent="-342900">
+              <a:spcAft>
+                <a:spcPts val="1000"/>
+              </a:spcAft>
+              <a:buSzPct val="100000"/>
+              <a:buChar char="•"/>
             </a:pPr>
             <a:r>
-              <a:rPr lang="en-US" sz="1400" dirty="0">
-                <a:solidFill>
-                  <a:schemeClr val="tx2"/>
+              <a:rPr lang="en-US" sz="1350" dirty="0">
+                <a:solidFill>
+                  <a:schemeClr val="tx1"/>
                 </a:solidFill>
               </a:rPr>
-              <a:t>El módulo de muelle que exige H3 (CU04 y CU10) no existe: ningún requerimiento lo recogió. RF‑027 aporta las reglas que aplicará. Entra al Sprint 3.</a:t>
+              <a:t>Identificar cada binario por su resumen SHA‑256</a:t>
             </a:r>
-            <a:endParaRPr lang="en-US" sz="1400" dirty="0"/>
-          </a:p>
-        </p:txBody>
-      </p:sp>
-      <p:sp>
-        <p:nvSpPr>
-          <p:cNvPr id="13" name="hipotesis-2"/>
+            <a:endParaRPr lang="en-US" sz="1350" dirty="0"/>
+          </a:p>
+          <a:p>
+            <a:pPr marL="342900" indent="-342900">
+              <a:spcAft>
+                <a:spcPts val="1000"/>
+              </a:spcAft>
+              <a:buSzPct val="100000"/>
+              <a:buChar char="•"/>
+            </a:pPr>
+            <a:r>
+              <a:rPr lang="en-US" sz="1350" dirty="0">
+                <a:solidFill>
+                  <a:schemeClr val="tx1"/>
+                </a:solidFill>
+              </a:rPr>
+              <a:t>Dos programadores en paralelo, con reglas escritas</a:t>
+            </a:r>
+            <a:endParaRPr lang="en-US" sz="1350" dirty="0"/>
+          </a:p>
+          <a:p>
+            <a:pPr marL="342900" indent="-342900">
+              <a:spcAft>
+                <a:spcPts val="1000"/>
+              </a:spcAft>
+              <a:buSzPct val="100000"/>
+              <a:buChar char="•"/>
+            </a:pPr>
+            <a:r>
+              <a:rPr lang="en-US" sz="1350" dirty="0">
+                <a:solidFill>
+                  <a:schemeClr val="tx1"/>
+                </a:solidFill>
+              </a:rPr>
+              <a:t>La doble prueba: 9 casos en que una segunda revisión encontró un error</a:t>
+            </a:r>
+            <a:endParaRPr lang="en-US" sz="1350" dirty="0"/>
+          </a:p>
+        </p:txBody>
+      </p:sp>
+      <p:sp>
+        <p:nvSpPr>
+          <p:cNvPr id="13" name="retro-2"/>
           <p:cNvSpPr/>
           <p:nvPr/>
         </p:nvSpPr>
         <p:spPr>
           <a:xfrm>
             <a:off x="4352544" y="2011680"/>
-            <a:ext cx="3483864" cy="3017520"/>
+            <a:ext cx="3483864" cy="3246120"/>
           </a:xfrm>
           <a:prstGeom prst="rect">
             <a:avLst/>
@@ -5094,14 +5372,34 @@
       </p:sp>
       <p:sp>
         <p:nvSpPr>
-          <p:cNvPr id="14" name="hipotesis-2-codigo"/>
+          <p:cNvPr id="14" name="retro-2-marca"/>
+          <p:cNvSpPr/>
+          <p:nvPr/>
+        </p:nvSpPr>
+        <p:spPr>
+          <a:xfrm>
+            <a:off x="4581144" y="2258568"/>
+            <a:ext cx="201168" cy="201168"/>
+          </a:xfrm>
+          <a:prstGeom prst="ellipse">
+            <a:avLst/>
+          </a:prstGeom>
+          <a:solidFill>
+            <a:schemeClr val="accent3"/>
+          </a:solidFill>
+          <a:ln/>
+        </p:spPr>
+      </p:sp>
+      <p:sp>
+        <p:nvSpPr>
+          <p:cNvPr id="15" name="retro-2-titulo"/>
           <p:cNvSpPr txBox="1"/>
           <p:nvPr/>
         </p:nvSpPr>
         <p:spPr>
           <a:xfrm>
-            <a:off x="4581144" y="2194560"/>
-            <a:ext cx="1097280" cy="685800"/>
+            <a:off x="4901184" y="2176272"/>
+            <a:ext cx="2706624" cy="365760"/>
           </a:xfrm>
           <a:prstGeom prst="rect">
             <a:avLst/>
@@ -5117,30 +5415,30 @@
               <a:buNone/>
             </a:pPr>
             <a:r>
-              <a:rPr lang="en-US" sz="3600" b="1" dirty="0">
-                <a:solidFill>
-                  <a:schemeClr val="accent1"/>
+              <a:rPr lang="en-US" sz="1800" b="1" dirty="0">
+                <a:solidFill>
+                  <a:schemeClr val="tx1"/>
                 </a:solidFill>
                 <a:latin typeface="Cambria" pitchFamily="34" charset="0"/>
                 <a:ea typeface="Cambria" pitchFamily="34" charset="-122"/>
                 <a:cs typeface="Cambria" pitchFamily="34" charset="-120"/>
               </a:rPr>
-              <a:t>H4</a:t>
+              <a:t>No funcionó</a:t>
             </a:r>
-            <a:endParaRPr lang="en-US" sz="3600" dirty="0"/>
-          </a:p>
-        </p:txBody>
-      </p:sp>
-      <p:sp>
-        <p:nvSpPr>
-          <p:cNvPr id="15" name="hipotesis-2-nombre"/>
+            <a:endParaRPr lang="en-US" sz="1800" dirty="0"/>
+          </a:p>
+        </p:txBody>
+      </p:sp>
+      <p:sp>
+        <p:nvSpPr>
+          <p:cNvPr id="16" name="retro-2-lista"/>
           <p:cNvSpPr txBox="1"/>
           <p:nvPr/>
         </p:nvSpPr>
         <p:spPr>
           <a:xfrm>
-            <a:off x="4581144" y="2926080"/>
-            <a:ext cx="3026664" cy="411480"/>
+            <a:off x="4535424" y="2697480"/>
+            <a:ext cx="3118104" cy="2377440"/>
           </a:xfrm>
           <a:prstGeom prst="rect">
             <a:avLst/>
@@ -5149,70 +5447,110 @@
           <a:ln/>
         </p:spPr>
         <p:txBody>
-          <a:bodyPr wrap="square" lIns="0" tIns="0" rIns="0" bIns="0" rtlCol="0" anchor="ctr"/>
+          <a:bodyPr wrap="square" lIns="0" tIns="0" rIns="0" bIns="0" rtlCol="0" anchor="t"/>
           <a:lstStyle/>
           <a:p>
-            <a:pPr indent="0" marL="0">
-              <a:buNone/>
+            <a:pPr marL="342900" indent="-342900">
+              <a:spcAft>
+                <a:spcPts val="1000"/>
+              </a:spcAft>
+              <a:buSzPct val="100000"/>
+              <a:buChar char="•"/>
             </a:pPr>
             <a:r>
-              <a:rPr lang="en-US" sz="1500" b="1" dirty="0">
+              <a:rPr lang="en-US" sz="1350" dirty="0">
                 <a:solidFill>
                   <a:schemeClr val="tx1"/>
                 </a:solidFill>
               </a:rPr>
-              <a:t>Una sola base de código</a:t>
+              <a:t>Los trámites externos empezaron el día 13, no el primero</a:t>
             </a:r>
-            <a:endParaRPr lang="en-US" sz="1500" dirty="0"/>
-          </a:p>
-        </p:txBody>
-      </p:sp>
-      <p:sp>
-        <p:nvSpPr>
-          <p:cNvPr id="16" name="hipotesis-2-texto"/>
-          <p:cNvSpPr txBox="1"/>
-          <p:nvPr/>
-        </p:nvSpPr>
-        <p:spPr>
-          <a:xfrm>
-            <a:off x="4581144" y="3429000"/>
-            <a:ext cx="3026664" cy="2011680"/>
-          </a:xfrm>
-          <a:prstGeom prst="rect">
-            <a:avLst/>
-          </a:prstGeom>
-          <a:noFill/>
-          <a:ln/>
-        </p:spPr>
-        <p:txBody>
-          <a:bodyPr wrap="square" lIns="0" tIns="0" rIns="0" bIns="0" rtlCol="0" anchor="t"/>
-          <a:lstStyle/>
-          <a:p>
-            <a:pPr indent="0" marL="0">
-              <a:buNone/>
+            <a:endParaRPr lang="en-US" sz="1350" dirty="0"/>
+          </a:p>
+          <a:p>
+            <a:pPr marL="342900" indent="-342900">
+              <a:spcAft>
+                <a:spcPts val="1000"/>
+              </a:spcAft>
+              <a:buSzPct val="100000"/>
+              <a:buChar char="•"/>
             </a:pPr>
             <a:r>
-              <a:rPr lang="en-US" sz="1400" dirty="0">
-                <a:solidFill>
-                  <a:schemeClr val="tx2"/>
+              <a:rPr lang="en-US" sz="1350" dirty="0">
+                <a:solidFill>
+                  <a:schemeClr val="tx1"/>
                 </a:solidFill>
               </a:rPr>
-              <a:t>Nada se implementó dos veces. Pero la verificación no se comparte: las diferencias que importaron fueron de plataforma, no de código.</a:t>
+              <a:t>Las alertas automáticas, sin facturación</a:t>
             </a:r>
-            <a:endParaRPr lang="en-US" sz="1400" dirty="0"/>
-          </a:p>
-        </p:txBody>
-      </p:sp>
-      <p:sp>
-        <p:nvSpPr>
-          <p:cNvPr id="17" name="hipotesis-3"/>
+            <a:endParaRPr lang="en-US" sz="1350" dirty="0"/>
+          </a:p>
+          <a:p>
+            <a:pPr marL="342900" indent="-342900">
+              <a:spcAft>
+                <a:spcPts val="1000"/>
+              </a:spcAft>
+              <a:buSzPct val="100000"/>
+              <a:buChar char="•"/>
+            </a:pPr>
+            <a:r>
+              <a:rPr lang="en-US" sz="1350" dirty="0">
+                <a:solidFill>
+                  <a:schemeClr val="tx1"/>
+                </a:solidFill>
+              </a:rPr>
+              <a:t>La Web sin conexión</a:t>
+            </a:r>
+            <a:endParaRPr lang="en-US" sz="1350" dirty="0"/>
+          </a:p>
+          <a:p>
+            <a:pPr marL="342900" indent="-342900">
+              <a:spcAft>
+                <a:spcPts val="1000"/>
+              </a:spcAft>
+              <a:buSzPct val="100000"/>
+              <a:buChar char="•"/>
+            </a:pPr>
+            <a:r>
+              <a:rPr lang="en-US" sz="1350" dirty="0">
+                <a:solidFill>
+                  <a:schemeClr val="tx1"/>
+                </a:solidFill>
+              </a:rPr>
+              <a:t>Requerimientos no funcionales no verificables tal como se escribieron</a:t>
+            </a:r>
+            <a:endParaRPr lang="en-US" sz="1350" dirty="0"/>
+          </a:p>
+          <a:p>
+            <a:pPr marL="342900" indent="-342900">
+              <a:spcAft>
+                <a:spcPts val="1000"/>
+              </a:spcAft>
+              <a:buSzPct val="100000"/>
+              <a:buChar char="•"/>
+            </a:pPr>
+            <a:r>
+              <a:rPr lang="en-US" sz="1350" dirty="0">
+                <a:solidFill>
+                  <a:schemeClr val="tx1"/>
+                </a:solidFill>
+              </a:rPr>
+              <a:t>La aceptación no revisó lo que muestra la pantalla</a:t>
+            </a:r>
+            <a:endParaRPr lang="en-US" sz="1350" dirty="0"/>
+          </a:p>
+        </p:txBody>
+      </p:sp>
+      <p:sp>
+        <p:nvSpPr>
+          <p:cNvPr id="17" name="retro-3"/>
           <p:cNvSpPr/>
           <p:nvPr/>
         </p:nvSpPr>
         <p:spPr>
           <a:xfrm>
             <a:off x="8065008" y="2011680"/>
-            <a:ext cx="3483864" cy="3017520"/>
+            <a:ext cx="3483864" cy="3246120"/>
           </a:xfrm>
           <a:prstGeom prst="rect">
             <a:avLst/>
@@ -5230,14 +5568,34 @@
       </p:sp>
       <p:sp>
         <p:nvSpPr>
-          <p:cNvPr id="18" name="hipotesis-3-codigo"/>
+          <p:cNvPr id="18" name="retro-3-marca"/>
+          <p:cNvSpPr/>
+          <p:nvPr/>
+        </p:nvSpPr>
+        <p:spPr>
+          <a:xfrm>
+            <a:off x="8293608" y="2258568"/>
+            <a:ext cx="201168" cy="201168"/>
+          </a:xfrm>
+          <a:prstGeom prst="ellipse">
+            <a:avLst/>
+          </a:prstGeom>
+          <a:solidFill>
+            <a:schemeClr val="accent4"/>
+          </a:solidFill>
+          <a:ln/>
+        </p:spPr>
+      </p:sp>
+      <p:sp>
+        <p:nvSpPr>
+          <p:cNvPr id="19" name="retro-3-titulo"/>
           <p:cNvSpPr txBox="1"/>
           <p:nvPr/>
         </p:nvSpPr>
         <p:spPr>
           <a:xfrm>
-            <a:off x="8293608" y="2194560"/>
-            <a:ext cx="1097280" cy="685800"/>
+            <a:off x="8613648" y="2176272"/>
+            <a:ext cx="2706624" cy="365760"/>
           </a:xfrm>
           <a:prstGeom prst="rect">
             <a:avLst/>
@@ -5253,30 +5611,142 @@
               <a:buNone/>
             </a:pPr>
             <a:r>
-              <a:rPr lang="en-US" sz="3600" b="1" dirty="0">
-                <a:solidFill>
-                  <a:schemeClr val="accent1"/>
+              <a:rPr lang="en-US" sz="1800" b="1" dirty="0">
+                <a:solidFill>
+                  <a:schemeClr val="tx1"/>
                 </a:solidFill>
                 <a:latin typeface="Cambria" pitchFamily="34" charset="0"/>
                 <a:ea typeface="Cambria" pitchFamily="34" charset="-122"/>
                 <a:cs typeface="Cambria" pitchFamily="34" charset="-120"/>
               </a:rPr>
-              <a:t>H5</a:t>
+              <a:t>Cambia</a:t>
             </a:r>
-            <a:endParaRPr lang="en-US" sz="3600" dirty="0"/>
-          </a:p>
-        </p:txBody>
-      </p:sp>
-      <p:sp>
-        <p:nvSpPr>
-          <p:cNvPr id="19" name="hipotesis-3-nombre"/>
+            <a:endParaRPr lang="en-US" sz="1800" dirty="0"/>
+          </a:p>
+        </p:txBody>
+      </p:sp>
+      <p:sp>
+        <p:nvSpPr>
+          <p:cNvPr id="20" name="retro-3-lista"/>
           <p:cNvSpPr txBox="1"/>
           <p:nvPr/>
         </p:nvSpPr>
         <p:spPr>
           <a:xfrm>
-            <a:off x="8293608" y="2926080"/>
-            <a:ext cx="3026664" cy="411480"/>
+            <a:off x="8247888" y="2697480"/>
+            <a:ext cx="3118104" cy="2377440"/>
+          </a:xfrm>
+          <a:prstGeom prst="rect">
+            <a:avLst/>
+          </a:prstGeom>
+          <a:noFill/>
+          <a:ln/>
+        </p:spPr>
+        <p:txBody>
+          <a:bodyPr wrap="square" lIns="0" tIns="0" rIns="0" bIns="0" rtlCol="0" anchor="t"/>
+          <a:lstStyle/>
+          <a:p>
+            <a:pPr marL="342900" indent="-342900">
+              <a:spcAft>
+                <a:spcPts val="1000"/>
+              </a:spcAft>
+              <a:buSzPct val="100000"/>
+              <a:buChar char="•"/>
+            </a:pPr>
+            <a:r>
+              <a:rPr lang="en-US" sz="1350" dirty="0">
+                <a:solidFill>
+                  <a:schemeClr val="tx1"/>
+                </a:solidFill>
+              </a:rPr>
+              <a:t>Decidir al planificar qué RNF se miden</a:t>
+            </a:r>
+            <a:endParaRPr lang="en-US" sz="1350" dirty="0"/>
+          </a:p>
+          <a:p>
+            <a:pPr marL="342900" indent="-342900">
+              <a:spcAft>
+                <a:spcPts val="1000"/>
+              </a:spcAft>
+              <a:buSzPct val="100000"/>
+              <a:buChar char="•"/>
+            </a:pPr>
+            <a:r>
+              <a:rPr lang="en-US" sz="1350" dirty="0">
+                <a:solidFill>
+                  <a:schemeClr val="tx1"/>
+                </a:solidFill>
+              </a:rPr>
+              <a:t>Abrir la prueba cerrada en cuanto exista la interna, con 12 testers listos</a:t>
+            </a:r>
+            <a:endParaRPr lang="en-US" sz="1350" dirty="0"/>
+          </a:p>
+          <a:p>
+            <a:pPr marL="342900" indent="-342900">
+              <a:spcAft>
+                <a:spcPts val="1000"/>
+              </a:spcAft>
+              <a:buSzPct val="100000"/>
+              <a:buChar char="•"/>
+            </a:pPr>
+            <a:r>
+              <a:rPr lang="en-US" sz="1350" dirty="0">
+                <a:solidFill>
+                  <a:schemeClr val="tx1"/>
+                </a:solidFill>
+              </a:rPr>
+              <a:t>Política de privacidad en la app, ícono propio y respaldo automático</a:t>
+            </a:r>
+            <a:endParaRPr lang="en-US" sz="1350" dirty="0"/>
+          </a:p>
+          <a:p>
+            <a:pPr marL="342900" indent="-342900">
+              <a:spcAft>
+                <a:spcPts val="1000"/>
+              </a:spcAft>
+              <a:buSzPct val="100000"/>
+              <a:buChar char="•"/>
+            </a:pPr>
+            <a:r>
+              <a:rPr lang="en-US" sz="1350" dirty="0">
+                <a:solidFill>
+                  <a:schemeClr val="tx1"/>
+                </a:solidFill>
+              </a:rPr>
+              <a:t>Convertir en requerimiento el módulo de muelle (CU04 y CU10)</a:t>
+            </a:r>
+            <a:endParaRPr lang="en-US" sz="1350" dirty="0"/>
+          </a:p>
+          <a:p>
+            <a:pPr marL="342900" indent="-342900">
+              <a:spcAft>
+                <a:spcPts val="1000"/>
+              </a:spcAft>
+              <a:buSzPct val="100000"/>
+              <a:buChar char="•"/>
+            </a:pPr>
+            <a:r>
+              <a:rPr lang="en-US" sz="1350" dirty="0">
+                <a:solidFill>
+                  <a:schemeClr val="tx1"/>
+                </a:solidFill>
+              </a:rPr>
+              <a:t>Probar cada incremento con una operación real</a:t>
+            </a:r>
+            <a:endParaRPr lang="en-US" sz="1350" dirty="0"/>
+          </a:p>
+        </p:txBody>
+      </p:sp>
+      <p:sp>
+        <p:nvSpPr>
+          <p:cNvPr id="21" name="retro-cierre"/>
+          <p:cNvSpPr txBox="1"/>
+          <p:nvPr/>
+        </p:nvSpPr>
+        <p:spPr>
+          <a:xfrm>
+            <a:off x="640080" y="5440680"/>
+            <a:ext cx="10908792" cy="457200"/>
           </a:xfrm>
           <a:prstGeom prst="rect">
             <a:avLst/>
@@ -5292,50 +5762,14 @@
               <a:buNone/>
             </a:pPr>
             <a:r>
-              <a:rPr lang="en-US" sz="1500" b="1" dirty="0">
-                <a:solidFill>
-                  <a:schemeClr val="tx1"/>
+              <a:rPr lang="en-US" sz="1250" i="1" dirty="0">
+                <a:solidFill>
+                  <a:schemeClr val="tx2"/>
                 </a:solidFill>
               </a:rPr>
-              <a:t>Sincronización con Firestore</a:t>
+              <a:t>Tres de los nueve errores de la doble prueba eran de quien planificaba y auditaba, y uno del propio autor: la verificación no distingue roles.</a:t>
             </a:r>
-            <a:endParaRPr lang="en-US" sz="1500" dirty="0"/>
-          </a:p>
-        </p:txBody>
-      </p:sp>
-      <p:sp>
-        <p:nvSpPr>
-          <p:cNvPr id="20" name="hipotesis-3-texto"/>
-          <p:cNvSpPr txBox="1"/>
-          <p:nvPr/>
-        </p:nvSpPr>
-        <p:spPr>
-          <a:xfrm>
-            <a:off x="8293608" y="3429000"/>
-            <a:ext cx="3026664" cy="2011680"/>
-          </a:xfrm>
-          <a:prstGeom prst="rect">
-            <a:avLst/>
-          </a:prstGeom>
-          <a:noFill/>
-          <a:ln/>
-        </p:spPr>
-        <p:txBody>
-          <a:bodyPr wrap="square" lIns="0" tIns="0" rIns="0" bIns="0" rtlCol="0" anchor="t"/>
-          <a:lstStyle/>
-          <a:p>
-            <a:pPr indent="0" marL="0">
-              <a:buNone/>
-            </a:pPr>
-            <a:r>
-              <a:rPr lang="en-US" sz="1400" dirty="0">
-                <a:solidFill>
-                  <a:schemeClr val="tx2"/>
-                </a:solidFill>
-              </a:rPr>
-              <a:t>La serie de 30 eventos está preservada. El producto funciona sin conexión pero no sincroniza: la latencia de H5 corresponde a la instrumentación.</a:t>
-            </a:r>
-            <a:endParaRPr lang="en-US" sz="1400" dirty="0"/>
+            <a:endParaRPr lang="en-US" sz="1250" dirty="0"/>
           </a:p>
         </p:txBody>
       </p:sp>
@@ -5438,6 +5872,666 @@
             <a:r>
               <a:rPr lang="en-US" sz="3000" b="1" dirty="0">
                 <a:solidFill>
+                  <a:schemeClr val="tx1"/>
+                </a:solidFill>
+                <a:latin typeface="Cambria" pitchFamily="34" charset="0"/>
+                <a:ea typeface="Cambria" pitchFamily="34" charset="-122"/>
+                <a:cs typeface="Cambria" pitchFamily="34" charset="-120"/>
+              </a:rPr>
+              <a:t>Lo que el incremento implica para las hipótesis</a:t>
+            </a:r>
+            <a:endParaRPr lang="en-US" sz="3000" dirty="0"/>
+          </a:p>
+        </p:txBody>
+      </p:sp>
+      <p:sp>
+        <p:nvSpPr>
+          <p:cNvPr id="3" name="Text 0"/>
+          <p:cNvSpPr/>
+          <p:nvPr>
+            <p:ph idx="101" type="body" hasCustomPrompt="1"/>
+          </p:nvPr>
+        </p:nvSpPr>
+        <p:spPr>
+          <a:xfrm>
+            <a:off x="640080" y="1371600"/>
+            <a:ext cx="10908792" cy="384048"/>
+          </a:xfrm>
+          <a:prstGeom prst="rect">
+            <a:avLst/>
+          </a:prstGeom>
+          <a:noFill/>
+          <a:ln/>
+        </p:spPr>
+        <p:txBody>
+          <a:bodyPr wrap="square" lIns="0" tIns="0" rIns="0" bIns="0" rtlCol="0" anchor="t"/>
+          <a:lstStyle/>
+          <a:p>
+            <a:pPr indent="0" marL="0">
+              <a:buNone/>
+            </a:pPr>
+            <a:r>
+              <a:rPr lang="en-US" sz="1400" dirty="0">
+                <a:solidFill>
+                  <a:schemeClr val="tx2"/>
+                </a:solidFill>
+                <a:latin typeface="Calibri" pitchFamily="34" charset="0"/>
+                <a:ea typeface="Calibri" pitchFamily="34" charset="-122"/>
+                <a:cs typeface="Calibri" pitchFamily="34" charset="-120"/>
+              </a:rPr>
+              <a:t>Ningún indicador se mide todavía, y H3 espera un módulo que ningún requerimiento recogió.</a:t>
+            </a:r>
+            <a:endParaRPr lang="en-US" sz="1400" dirty="0"/>
+          </a:p>
+        </p:txBody>
+      </p:sp>
+      <p:sp>
+        <p:nvSpPr>
+          <p:cNvPr id="4" name="motivo-punto-1"/>
+          <p:cNvSpPr/>
+          <p:nvPr/>
+        </p:nvSpPr>
+        <p:spPr>
+          <a:xfrm>
+            <a:off x="640080" y="1133856"/>
+            <a:ext cx="118872" cy="118872"/>
+          </a:xfrm>
+          <a:prstGeom prst="rect">
+            <a:avLst/>
+          </a:prstGeom>
+          <a:solidFill>
+            <a:schemeClr val="accent1"/>
+          </a:solidFill>
+          <a:ln/>
+        </p:spPr>
+      </p:sp>
+      <p:sp>
+        <p:nvSpPr>
+          <p:cNvPr id="5" name="motivo-punto-2"/>
+          <p:cNvSpPr/>
+          <p:nvPr/>
+        </p:nvSpPr>
+        <p:spPr>
+          <a:xfrm>
+            <a:off x="804672" y="1133856"/>
+            <a:ext cx="118872" cy="118872"/>
+          </a:xfrm>
+          <a:prstGeom prst="rect">
+            <a:avLst/>
+          </a:prstGeom>
+          <a:solidFill>
+            <a:schemeClr val="accent1"/>
+          </a:solidFill>
+          <a:ln/>
+        </p:spPr>
+      </p:sp>
+      <p:sp>
+        <p:nvSpPr>
+          <p:cNvPr id="6" name="motivo-punto-3"/>
+          <p:cNvSpPr/>
+          <p:nvPr/>
+        </p:nvSpPr>
+        <p:spPr>
+          <a:xfrm>
+            <a:off x="969264" y="1133856"/>
+            <a:ext cx="118872" cy="118872"/>
+          </a:xfrm>
+          <a:prstGeom prst="rect">
+            <a:avLst/>
+          </a:prstGeom>
+          <a:solidFill>
+            <a:schemeClr val="accent1"/>
+          </a:solidFill>
+          <a:ln/>
+        </p:spPr>
+      </p:sp>
+      <p:sp>
+        <p:nvSpPr>
+          <p:cNvPr id="7" name="motivo-punto-4"/>
+          <p:cNvSpPr/>
+          <p:nvPr/>
+        </p:nvSpPr>
+        <p:spPr>
+          <a:xfrm>
+            <a:off x="1133856" y="1133856"/>
+            <a:ext cx="118872" cy="118872"/>
+          </a:xfrm>
+          <a:prstGeom prst="rect">
+            <a:avLst/>
+          </a:prstGeom>
+          <a:solidFill>
+            <a:schemeClr val="accent1"/>
+          </a:solidFill>
+          <a:ln/>
+        </p:spPr>
+      </p:sp>
+      <p:sp>
+        <p:nvSpPr>
+          <p:cNvPr id="8" name="motivo-punto-5"/>
+          <p:cNvSpPr/>
+          <p:nvPr/>
+        </p:nvSpPr>
+        <p:spPr>
+          <a:xfrm>
+            <a:off x="1298448" y="1133856"/>
+            <a:ext cx="118872" cy="118872"/>
+          </a:xfrm>
+          <a:prstGeom prst="rect">
+            <a:avLst/>
+          </a:prstGeom>
+          <a:solidFill>
+            <a:schemeClr val="accent1"/>
+          </a:solidFill>
+          <a:ln/>
+        </p:spPr>
+      </p:sp>
+      <p:sp>
+        <p:nvSpPr>
+          <p:cNvPr id="9" name="hipotesis-1"/>
+          <p:cNvSpPr/>
+          <p:nvPr/>
+        </p:nvSpPr>
+        <p:spPr>
+          <a:xfrm>
+            <a:off x="640080" y="2011680"/>
+            <a:ext cx="3483864" cy="3017520"/>
+          </a:xfrm>
+          <a:prstGeom prst="rect">
+            <a:avLst/>
+          </a:prstGeom>
+          <a:solidFill>
+            <a:schemeClr val="bg2"/>
+          </a:solidFill>
+          <a:ln w="9525">
+            <a:solidFill>
+              <a:srgbClr val="D6D2CB"/>
+            </a:solidFill>
+            <a:prstDash val="solid"/>
+          </a:ln>
+        </p:spPr>
+      </p:sp>
+      <p:sp>
+        <p:nvSpPr>
+          <p:cNvPr id="10" name="hipotesis-1-codigo"/>
+          <p:cNvSpPr txBox="1"/>
+          <p:nvPr/>
+        </p:nvSpPr>
+        <p:spPr>
+          <a:xfrm>
+            <a:off x="868680" y="2194560"/>
+            <a:ext cx="1097280" cy="685800"/>
+          </a:xfrm>
+          <a:prstGeom prst="rect">
+            <a:avLst/>
+          </a:prstGeom>
+          <a:noFill/>
+          <a:ln/>
+        </p:spPr>
+        <p:txBody>
+          <a:bodyPr wrap="square" lIns="0" tIns="0" rIns="0" bIns="0" rtlCol="0" anchor="ctr"/>
+          <a:lstStyle/>
+          <a:p>
+            <a:pPr indent="0" marL="0">
+              <a:buNone/>
+            </a:pPr>
+            <a:r>
+              <a:rPr lang="en-US" sz="3600" b="1" dirty="0">
+                <a:solidFill>
+                  <a:schemeClr val="accent1"/>
+                </a:solidFill>
+                <a:latin typeface="Cambria" pitchFamily="34" charset="0"/>
+                <a:ea typeface="Cambria" pitchFamily="34" charset="-122"/>
+                <a:cs typeface="Cambria" pitchFamily="34" charset="-120"/>
+              </a:rPr>
+              <a:t>H3</a:t>
+            </a:r>
+            <a:endParaRPr lang="en-US" sz="3600" dirty="0"/>
+          </a:p>
+        </p:txBody>
+      </p:sp>
+      <p:sp>
+        <p:nvSpPr>
+          <p:cNvPr id="11" name="hipotesis-1-nombre"/>
+          <p:cNvSpPr txBox="1"/>
+          <p:nvPr/>
+        </p:nvSpPr>
+        <p:spPr>
+          <a:xfrm>
+            <a:off x="868680" y="2926080"/>
+            <a:ext cx="3026664" cy="411480"/>
+          </a:xfrm>
+          <a:prstGeom prst="rect">
+            <a:avLst/>
+          </a:prstGeom>
+          <a:noFill/>
+          <a:ln/>
+        </p:spPr>
+        <p:txBody>
+          <a:bodyPr wrap="square" lIns="0" tIns="0" rIns="0" bIns="0" rtlCol="0" anchor="ctr"/>
+          <a:lstStyle/>
+          <a:p>
+            <a:pPr indent="0" marL="0">
+              <a:buNone/>
+            </a:pPr>
+            <a:r>
+              <a:rPr lang="en-US" sz="1500" b="1" dirty="0">
+                <a:solidFill>
+                  <a:schemeClr val="tx1"/>
+                </a:solidFill>
+              </a:rPr>
+              <a:t>Validación preventiva</a:t>
+            </a:r>
+            <a:endParaRPr lang="en-US" sz="1500" dirty="0"/>
+          </a:p>
+        </p:txBody>
+      </p:sp>
+      <p:sp>
+        <p:nvSpPr>
+          <p:cNvPr id="12" name="hipotesis-1-texto"/>
+          <p:cNvSpPr txBox="1"/>
+          <p:nvPr/>
+        </p:nvSpPr>
+        <p:spPr>
+          <a:xfrm>
+            <a:off x="868680" y="3429000"/>
+            <a:ext cx="3026664" cy="2011680"/>
+          </a:xfrm>
+          <a:prstGeom prst="rect">
+            <a:avLst/>
+          </a:prstGeom>
+          <a:noFill/>
+          <a:ln/>
+        </p:spPr>
+        <p:txBody>
+          <a:bodyPr wrap="square" lIns="0" tIns="0" rIns="0" bIns="0" rtlCol="0" anchor="t"/>
+          <a:lstStyle/>
+          <a:p>
+            <a:pPr indent="0" marL="0">
+              <a:buNone/>
+            </a:pPr>
+            <a:r>
+              <a:rPr lang="en-US" sz="1400" dirty="0">
+                <a:solidFill>
+                  <a:schemeClr val="tx2"/>
+                </a:solidFill>
+              </a:rPr>
+              <a:t>El módulo de muelle que exige H3 (CU04 y CU10) no existe: ningún requerimiento lo recogió. RF‑027 aporta las reglas, y la prueba de campo, el procedimiento que reemplazará. Entra al Sprint 3.</a:t>
+            </a:r>
+            <a:endParaRPr lang="en-US" sz="1400" dirty="0"/>
+          </a:p>
+        </p:txBody>
+      </p:sp>
+      <p:sp>
+        <p:nvSpPr>
+          <p:cNvPr id="13" name="hipotesis-2"/>
+          <p:cNvSpPr/>
+          <p:nvPr/>
+        </p:nvSpPr>
+        <p:spPr>
+          <a:xfrm>
+            <a:off x="4352544" y="2011680"/>
+            <a:ext cx="3483864" cy="3017520"/>
+          </a:xfrm>
+          <a:prstGeom prst="rect">
+            <a:avLst/>
+          </a:prstGeom>
+          <a:solidFill>
+            <a:schemeClr val="bg2"/>
+          </a:solidFill>
+          <a:ln w="9525">
+            <a:solidFill>
+              <a:srgbClr val="D6D2CB"/>
+            </a:solidFill>
+            <a:prstDash val="solid"/>
+          </a:ln>
+        </p:spPr>
+      </p:sp>
+      <p:sp>
+        <p:nvSpPr>
+          <p:cNvPr id="14" name="hipotesis-2-codigo"/>
+          <p:cNvSpPr txBox="1"/>
+          <p:nvPr/>
+        </p:nvSpPr>
+        <p:spPr>
+          <a:xfrm>
+            <a:off x="4581144" y="2194560"/>
+            <a:ext cx="1097280" cy="685800"/>
+          </a:xfrm>
+          <a:prstGeom prst="rect">
+            <a:avLst/>
+          </a:prstGeom>
+          <a:noFill/>
+          <a:ln/>
+        </p:spPr>
+        <p:txBody>
+          <a:bodyPr wrap="square" lIns="0" tIns="0" rIns="0" bIns="0" rtlCol="0" anchor="ctr"/>
+          <a:lstStyle/>
+          <a:p>
+            <a:pPr indent="0" marL="0">
+              <a:buNone/>
+            </a:pPr>
+            <a:r>
+              <a:rPr lang="en-US" sz="3600" b="1" dirty="0">
+                <a:solidFill>
+                  <a:schemeClr val="accent1"/>
+                </a:solidFill>
+                <a:latin typeface="Cambria" pitchFamily="34" charset="0"/>
+                <a:ea typeface="Cambria" pitchFamily="34" charset="-122"/>
+                <a:cs typeface="Cambria" pitchFamily="34" charset="-120"/>
+              </a:rPr>
+              <a:t>H4</a:t>
+            </a:r>
+            <a:endParaRPr lang="en-US" sz="3600" dirty="0"/>
+          </a:p>
+        </p:txBody>
+      </p:sp>
+      <p:sp>
+        <p:nvSpPr>
+          <p:cNvPr id="15" name="hipotesis-2-nombre"/>
+          <p:cNvSpPr txBox="1"/>
+          <p:nvPr/>
+        </p:nvSpPr>
+        <p:spPr>
+          <a:xfrm>
+            <a:off x="4581144" y="2926080"/>
+            <a:ext cx="3026664" cy="411480"/>
+          </a:xfrm>
+          <a:prstGeom prst="rect">
+            <a:avLst/>
+          </a:prstGeom>
+          <a:noFill/>
+          <a:ln/>
+        </p:spPr>
+        <p:txBody>
+          <a:bodyPr wrap="square" lIns="0" tIns="0" rIns="0" bIns="0" rtlCol="0" anchor="ctr"/>
+          <a:lstStyle/>
+          <a:p>
+            <a:pPr indent="0" marL="0">
+              <a:buNone/>
+            </a:pPr>
+            <a:r>
+              <a:rPr lang="en-US" sz="1500" b="1" dirty="0">
+                <a:solidFill>
+                  <a:schemeClr val="tx1"/>
+                </a:solidFill>
+              </a:rPr>
+              <a:t>Una sola base de código</a:t>
+            </a:r>
+            <a:endParaRPr lang="en-US" sz="1500" dirty="0"/>
+          </a:p>
+        </p:txBody>
+      </p:sp>
+      <p:sp>
+        <p:nvSpPr>
+          <p:cNvPr id="16" name="hipotesis-2-texto"/>
+          <p:cNvSpPr txBox="1"/>
+          <p:nvPr/>
+        </p:nvSpPr>
+        <p:spPr>
+          <a:xfrm>
+            <a:off x="4581144" y="3429000"/>
+            <a:ext cx="3026664" cy="2011680"/>
+          </a:xfrm>
+          <a:prstGeom prst="rect">
+            <a:avLst/>
+          </a:prstGeom>
+          <a:noFill/>
+          <a:ln/>
+        </p:spPr>
+        <p:txBody>
+          <a:bodyPr wrap="square" lIns="0" tIns="0" rIns="0" bIns="0" rtlCol="0" anchor="t"/>
+          <a:lstStyle/>
+          <a:p>
+            <a:pPr indent="0" marL="0">
+              <a:buNone/>
+            </a:pPr>
+            <a:r>
+              <a:rPr lang="en-US" sz="1400" dirty="0">
+                <a:solidFill>
+                  <a:schemeClr val="tx2"/>
+                </a:solidFill>
+              </a:rPr>
+              <a:t>Nada se implementó dos veces. Pero la verificación no se comparte: las diferencias que importaron fueron de plataforma, no de código.</a:t>
+            </a:r>
+            <a:endParaRPr lang="en-US" sz="1400" dirty="0"/>
+          </a:p>
+        </p:txBody>
+      </p:sp>
+      <p:sp>
+        <p:nvSpPr>
+          <p:cNvPr id="17" name="hipotesis-3"/>
+          <p:cNvSpPr/>
+          <p:nvPr/>
+        </p:nvSpPr>
+        <p:spPr>
+          <a:xfrm>
+            <a:off x="8065008" y="2011680"/>
+            <a:ext cx="3483864" cy="3017520"/>
+          </a:xfrm>
+          <a:prstGeom prst="rect">
+            <a:avLst/>
+          </a:prstGeom>
+          <a:solidFill>
+            <a:schemeClr val="bg2"/>
+          </a:solidFill>
+          <a:ln w="9525">
+            <a:solidFill>
+              <a:srgbClr val="D6D2CB"/>
+            </a:solidFill>
+            <a:prstDash val="solid"/>
+          </a:ln>
+        </p:spPr>
+      </p:sp>
+      <p:sp>
+        <p:nvSpPr>
+          <p:cNvPr id="18" name="hipotesis-3-codigo"/>
+          <p:cNvSpPr txBox="1"/>
+          <p:nvPr/>
+        </p:nvSpPr>
+        <p:spPr>
+          <a:xfrm>
+            <a:off x="8293608" y="2194560"/>
+            <a:ext cx="1097280" cy="685800"/>
+          </a:xfrm>
+          <a:prstGeom prst="rect">
+            <a:avLst/>
+          </a:prstGeom>
+          <a:noFill/>
+          <a:ln/>
+        </p:spPr>
+        <p:txBody>
+          <a:bodyPr wrap="square" lIns="0" tIns="0" rIns="0" bIns="0" rtlCol="0" anchor="ctr"/>
+          <a:lstStyle/>
+          <a:p>
+            <a:pPr indent="0" marL="0">
+              <a:buNone/>
+            </a:pPr>
+            <a:r>
+              <a:rPr lang="en-US" sz="3600" b="1" dirty="0">
+                <a:solidFill>
+                  <a:schemeClr val="accent1"/>
+                </a:solidFill>
+                <a:latin typeface="Cambria" pitchFamily="34" charset="0"/>
+                <a:ea typeface="Cambria" pitchFamily="34" charset="-122"/>
+                <a:cs typeface="Cambria" pitchFamily="34" charset="-120"/>
+              </a:rPr>
+              <a:t>H5</a:t>
+            </a:r>
+            <a:endParaRPr lang="en-US" sz="3600" dirty="0"/>
+          </a:p>
+        </p:txBody>
+      </p:sp>
+      <p:sp>
+        <p:nvSpPr>
+          <p:cNvPr id="19" name="hipotesis-3-nombre"/>
+          <p:cNvSpPr txBox="1"/>
+          <p:nvPr/>
+        </p:nvSpPr>
+        <p:spPr>
+          <a:xfrm>
+            <a:off x="8293608" y="2926080"/>
+            <a:ext cx="3026664" cy="411480"/>
+          </a:xfrm>
+          <a:prstGeom prst="rect">
+            <a:avLst/>
+          </a:prstGeom>
+          <a:noFill/>
+          <a:ln/>
+        </p:spPr>
+        <p:txBody>
+          <a:bodyPr wrap="square" lIns="0" tIns="0" rIns="0" bIns="0" rtlCol="0" anchor="ctr"/>
+          <a:lstStyle/>
+          <a:p>
+            <a:pPr indent="0" marL="0">
+              <a:buNone/>
+            </a:pPr>
+            <a:r>
+              <a:rPr lang="en-US" sz="1500" b="1" dirty="0">
+                <a:solidFill>
+                  <a:schemeClr val="tx1"/>
+                </a:solidFill>
+              </a:rPr>
+              <a:t>Sincronización con Firestore</a:t>
+            </a:r>
+            <a:endParaRPr lang="en-US" sz="1500" dirty="0"/>
+          </a:p>
+        </p:txBody>
+      </p:sp>
+      <p:sp>
+        <p:nvSpPr>
+          <p:cNvPr id="20" name="hipotesis-3-texto"/>
+          <p:cNvSpPr txBox="1"/>
+          <p:nvPr/>
+        </p:nvSpPr>
+        <p:spPr>
+          <a:xfrm>
+            <a:off x="8293608" y="3429000"/>
+            <a:ext cx="3026664" cy="2011680"/>
+          </a:xfrm>
+          <a:prstGeom prst="rect">
+            <a:avLst/>
+          </a:prstGeom>
+          <a:noFill/>
+          <a:ln/>
+        </p:spPr>
+        <p:txBody>
+          <a:bodyPr wrap="square" lIns="0" tIns="0" rIns="0" bIns="0" rtlCol="0" anchor="t"/>
+          <a:lstStyle/>
+          <a:p>
+            <a:pPr indent="0" marL="0">
+              <a:buNone/>
+            </a:pPr>
+            <a:r>
+              <a:rPr lang="en-US" sz="1400" dirty="0">
+                <a:solidFill>
+                  <a:schemeClr val="tx2"/>
+                </a:solidFill>
+              </a:rPr>
+              <a:t>La serie de 30 eventos está preservada. El producto funciona sin conexión pero no sincroniza: la latencia de H5 corresponde a la instrumentación.</a:t>
+            </a:r>
+            <a:endParaRPr lang="en-US" sz="1400" dirty="0"/>
+          </a:p>
+        </p:txBody>
+      </p:sp>
+      <p:sp>
+        <p:nvSpPr>
+          <p:cNvPr id="25" name="Slide Number Placeholder 0"/>
+          <p:cNvSpPr>
+            <a:spLocks noGrp="1"/>
+          </p:cNvSpPr>
+          <p:nvPr>
+            <p:ph type="sldNum" sz="quarter" idx="4294967295"/>
+          </p:nvPr>
+        </p:nvSpPr>
+        <p:spPr>
+          <a:xfrm>
+            <a:off x="11064240" y="6419088"/>
+            <a:ext cx="484632" cy="274320"/>
+          </a:xfrm>
+          <a:prstGeom prst="rect">
+            <a:avLst/>
+          </a:prstGeom>
+          <a:extLst>
+            <a:ext uri="{C572A759-6A51-4108-AA02-DFA0A04FC94B}">
+              <ma14:wrappingTextBoxFlag xmlns:ma14="http://schemas.microsoft.com/office/mac/drawingml/2011/main" val="0"/>
+            </a:ext>
+          </a:extLst>
+        </p:spPr>
+        <p:txBody>
+          <a:bodyPr/>
+          <a:lstStyle>
+            <a:lvl1pPr>
+              <a:defRPr sz="1000">
+                <a:solidFill>
+                  <a:srgbClr val="5E6B75"/>
+                </a:solidFill>
+              </a:defRPr>
+            </a:lvl1pPr>
+          </a:lstStyle>
+          <a:p>
+            <a:pPr algn="r"/>
+            <a:fld id="{F7021451-1387-4CA6-816F-3879F97B5CBC}" type="slidenum">
+              <a:rPr b="0" lang="en-US"/>
+              <a:t>13</a:t>
+            </a:fld>
+            <a:endParaRPr lang="en-US"/>
+          </a:p>
+        </p:txBody>
+      </p:sp>
+    </p:spTree>
+  </p:cSld>
+  <p:clrMapOvr>
+    <a:masterClrMapping/>
+  </p:clrMapOvr>
+</p:sld>
+</file>
+
+<file path=ppt/slides/slide14.xml><?xml version="1.0" encoding="utf-8"?>
+<p:sld xmlns:a="http://schemas.openxmlformats.org/drawingml/2006/main" xmlns:r="http://schemas.openxmlformats.org/officeDocument/2006/relationships" xmlns:p="http://schemas.openxmlformats.org/presentationml/2006/main">
+  <p:cSld name="Slide 14">
+    <p:spTree>
+      <p:nvGrpSpPr>
+        <p:cNvPr id="1" name=""/>
+        <p:cNvGrpSpPr/>
+        <p:nvPr/>
+      </p:nvGrpSpPr>
+      <p:grpSpPr>
+        <a:xfrm>
+          <a:off x="0" y="0"/>
+          <a:ext cx="0" cy="0"/>
+          <a:chOff x="0" y="0"/>
+          <a:chExt cx="0" cy="0"/>
+        </a:xfrm>
+      </p:grpSpPr>
+      <p:sp>
+        <p:nvSpPr>
+          <p:cNvPr id="2" name="Text 0"/>
+          <p:cNvSpPr/>
+          <p:nvPr>
+            <p:ph idx="100" type="title" hasCustomPrompt="1"/>
+          </p:nvPr>
+        </p:nvSpPr>
+        <p:spPr>
+          <a:xfrm>
+            <a:off x="640080" y="411480"/>
+            <a:ext cx="10908792" cy="658368"/>
+          </a:xfrm>
+          <a:prstGeom prst="rect">
+            <a:avLst/>
+          </a:prstGeom>
+          <a:noFill/>
+          <a:ln/>
+        </p:spPr>
+        <p:txBody>
+          <a:bodyPr wrap="square" lIns="0" tIns="0" rIns="0" bIns="0" rtlCol="0" anchor="b"/>
+          <a:lstStyle/>
+          <a:p>
+            <a:pPr algn="l" indent="0" marL="0">
+              <a:buNone/>
+            </a:pPr>
+            <a:r>
+              <a:rPr lang="en-US" sz="3000" b="1" dirty="0">
+                <a:solidFill>
                   <a:schemeClr val="bg1"/>
                 </a:solidFill>
                 <a:latin typeface="Cambria" pitchFamily="34" charset="0"/>
@@ -5485,7 +6579,7 @@
                 <a:ea typeface="Calibri" pitchFamily="34" charset="-122"/>
                 <a:cs typeface="Calibri" pitchFamily="34" charset="-120"/>
               </a:rPr>
-              <a:t>El sprint cumplió su objetivo; solo falta instalar desde Play la versión publicada.</a:t>
+              <a:t>El sprint cumplió su objetivo: 26 de 26 tareas y la app instalada desde Google Play.</a:t>
             </a:r>
             <a:endParaRPr lang="en-US" sz="1400" dirty="0"/>
           </a:p>
@@ -5677,7 +6771,7 @@
                   <a:srgbClr val="D6D2CB"/>
                 </a:solidFill>
               </a:rPr>
-              <a:t>25 de 26 tareas · 33.0 h · 282 pruebas · Web publicada</a:t>
+              <a:t>26 de 26 tareas · 35.0 h · 282 pruebas · Web publicada y app instalada desde Play</a:t>
             </a:r>
             <a:endParaRPr lang="en-US" sz="1400" dirty="0"/>
           </a:p>
@@ -5861,7 +6955,7 @@
                   <a:srgbClr val="D6D2CB"/>
                 </a:solidFill>
               </a:rPr>
-              <a:t>Prueba interna publicada el 3‑oct; instalar en el Honor y abrir la prueba cerrada</a:t>
+              <a:t>Prueba interna con la app instalada en el Honor; falta abrir la prueba cerrada con 12 testers</a:t>
             </a:r>
             <a:endParaRPr lang="en-US" sz="1400" dirty="0"/>
           </a:p>
@@ -6034,7 +7128,7 @@
             <a:pPr algn="r"/>
             <a:fld id="{F7021451-1387-4CA6-816F-3879F97B5CBC}" type="slidenum">
               <a:rPr b="0" lang="en-US"/>
-              <a:t>13</a:t>
+              <a:t>14</a:t>
             </a:fld>
             <a:endParaRPr lang="en-US"/>
           </a:p>
@@ -6141,7 +7235,7 @@
                 <a:ea typeface="Calibri" pitchFamily="34" charset="-122"/>
                 <a:cs typeface="Calibri" pitchFamily="34" charset="-120"/>
               </a:rPr>
-              <a:t>Estado al 3 de octubre de 2026. Solo falta instalar desde Google Play la versión ya publicada.</a:t>
+              <a:t>Estado al 6 de octubre de 2026. Las 26 tareas comprometidas están terminadas.</a:t>
             </a:r>
             <a:endParaRPr lang="en-US" sz="1400" dirty="0"/>
           </a:p>
@@ -6305,7 +7399,7 @@
                 <a:ea typeface="Cambria" pitchFamily="34" charset="-122"/>
                 <a:cs typeface="Cambria" pitchFamily="34" charset="-120"/>
               </a:rPr>
-              <a:t>25/26</a:t>
+              <a:t>26/26</a:t>
             </a:r>
             <a:endParaRPr lang="en-US" sz="3800" dirty="0"/>
           </a:p>
@@ -6377,7 +7471,7 @@
                   <a:schemeClr val="tx2"/>
                 </a:solidFill>
               </a:rPr>
-              <a:t>T‑49 publicada en la prueba interna; falta instalarla</a:t>
+              <a:t>La última, T‑49: la app instalada desde Google Play</a:t>
             </a:r>
             <a:endParaRPr lang="en-US" sz="1150" dirty="0"/>
           </a:p>
@@ -6441,7 +7535,7 @@
                 <a:ea typeface="Cambria" pitchFamily="34" charset="-122"/>
                 <a:cs typeface="Cambria" pitchFamily="34" charset="-120"/>
               </a:rPr>
-              <a:t>33.0 h</a:t>
+              <a:t>35.0 h</a:t>
             </a:r>
             <a:endParaRPr lang="en-US" sz="3800" dirty="0"/>
           </a:p>
@@ -6577,7 +7671,7 @@
                 <a:ea typeface="Cambria" pitchFamily="34" charset="-122"/>
                 <a:cs typeface="Cambria" pitchFamily="34" charset="-120"/>
               </a:rPr>
-              <a:t>49/57</a:t>
+              <a:t>57/57</a:t>
             </a:r>
             <a:endParaRPr lang="en-US" sz="3800" dirty="0"/>
           </a:p>
@@ -6649,7 +7743,7 @@
                   <a:schemeClr val="tx2"/>
                 </a:solidFill>
               </a:rPr>
-              <a:t>5 de 6 elementos completos</a:t>
+              <a:t>6 de 6 elementos completos</a:t>
             </a:r>
             <a:endParaRPr lang="en-US" sz="1150" dirty="0"/>
           </a:p>
@@ -8223,7 +9317,7 @@
             </a:avLst>
           </a:prstGeom>
           <a:solidFill>
-            <a:schemeClr val="accent1"/>
+            <a:schemeClr val="accent2"/>
           </a:solidFill>
           <a:ln/>
         </p:spPr>
@@ -8258,7 +9352,7 @@
                   <a:schemeClr val="bg1"/>
                 </a:solidFill>
               </a:rPr>
-              <a:t>En curso</a:t>
+              <a:t>Terminado</a:t>
             </a:r>
             <a:endParaRPr lang="en-US" sz="1050" dirty="0"/>
           </a:p>
@@ -8330,7 +9424,7 @@
                   <a:schemeClr val="tx2"/>
                 </a:solidFill>
               </a:rPr>
-              <a:t>Proyecto de producción, Web publicada y app en la prueba interna de Google Play; falta instalarla desde la tienda.</a:t>
+              <a:t>Proyecto de producción, Web publicada y app en la prueba interna de Google Play, instalada desde la tienda.</a:t>
             </a:r>
             <a:endParaRPr lang="en-US" sz="1250" dirty="0"/>
           </a:p>

</xml_diff>